<commit_message>
feat: implement document export utilities for PDF and PPTX and add SummaryView component
</commit_message>
<xml_diff>
--- a/AI_Study_Assistant_Summary.pptx
+++ b/AI_Study_Assistant_Summary.pptx
@@ -9,9 +9,11 @@
     <p:sldId id="257" r:id="rId3"/>
     <p:sldId id="258" r:id="rId4"/>
     <p:sldId id="259" r:id="rId5"/>
+    <p:sldId id="260" r:id="rId6"/>
+    <p:sldId id="261" r:id="rId7"/>
   </p:sldIdLst>
   <p:notesMasterIdLst>
-    <p:notesMasterId r:id="rId6"/>
+    <p:notesMasterId r:id="rId8"/>
   </p:notesMasterIdLst>
   <p:sldSz cx="9144000" cy="5143500"/>
   <p:notesSz cx="5143500" cy="9144000"/>
@@ -811,6 +813,182 @@
 </p:notes>
 </file>
 
+<file path=ppt/notesSlides/notesSlide5.xml><?xml version="1.0" encoding="utf-8"?>
+<p:notes xmlns:a="http://schemas.openxmlformats.org/drawingml/2006/main" xmlns:r="http://schemas.openxmlformats.org/officeDocument/2006/relationships" xmlns:p="http://schemas.openxmlformats.org/presentationml/2006/main">
+  <p:cSld>
+    <p:spTree>
+      <p:nvGrpSpPr>
+        <p:cNvPr id="1" name=""/>
+        <p:cNvGrpSpPr/>
+        <p:nvPr/>
+      </p:nvGrpSpPr>
+      <p:grpSpPr>
+        <a:xfrm>
+          <a:off x="0" y="0"/>
+          <a:ext cx="0" cy="0"/>
+          <a:chOff x="0" y="0"/>
+          <a:chExt cx="0" cy="0"/>
+        </a:xfrm>
+      </p:grpSpPr>
+      <p:sp>
+        <p:nvSpPr>
+          <p:cNvPr id="2" name="Slide Image Placeholder 1"/>
+          <p:cNvSpPr>
+            <a:spLocks noGrp="1" noRot="1" noChangeAspect="1"/>
+          </p:cNvSpPr>
+          <p:nvPr>
+            <p:ph type="sldImg"/>
+          </p:nvPr>
+        </p:nvSpPr>
+        <p:spPr/>
+      </p:sp>
+      <p:sp>
+        <p:nvSpPr>
+          <p:cNvPr id="3" name="Notes Placeholder 2"/>
+          <p:cNvSpPr>
+            <a:spLocks noGrp="1"/>
+          </p:cNvSpPr>
+          <p:nvPr>
+            <p:ph type="body" idx="1"/>
+          </p:nvPr>
+        </p:nvSpPr>
+        <p:spPr/>
+        <p:txBody>
+          <a:bodyPr/>
+          <a:lstStyle/>
+          <a:p>
+            <a:r>
+              <a:rPr lang="en-US" dirty="0"/>
+              <a:t/>
+            </a:r>
+            <a:endParaRPr lang="en-US" dirty="0"/>
+          </a:p>
+        </p:txBody>
+      </p:sp>
+      <p:sp>
+        <p:nvSpPr>
+          <p:cNvPr id="4" name="Slide Number Placeholder 3"/>
+          <p:cNvSpPr>
+            <a:spLocks noGrp="1"/>
+          </p:cNvSpPr>
+          <p:nvPr>
+            <p:ph type="sldNum" sz="quarter" idx="10"/>
+          </p:nvPr>
+        </p:nvSpPr>
+        <p:spPr/>
+        <p:txBody>
+          <a:bodyPr/>
+          <a:lstStyle/>
+          <a:p>
+            <a:fld id="{F7021451-1387-4CA6-816F-3879F97B5CBC}" type="slidenum">
+              <a:rPr lang="en-US"/>
+              <a:t>5</a:t>
+            </a:fld>
+            <a:endParaRPr lang="en-US"/>
+          </a:p>
+        </p:txBody>
+      </p:sp>
+    </p:spTree>
+    <p:extLst>
+      <p:ext uri="{BB962C8B-B14F-4D97-AF65-F5344CB8AC3E}">
+        <p14:creationId xmlns:p14="http://schemas.microsoft.com/office/powerpoint/2010/main" val="1024086991"/>
+      </p:ext>
+    </p:extLst>
+  </p:cSld>
+  <p:clrMapOvr>
+    <a:masterClrMapping/>
+  </p:clrMapOvr>
+</p:notes>
+</file>
+
+<file path=ppt/notesSlides/notesSlide6.xml><?xml version="1.0" encoding="utf-8"?>
+<p:notes xmlns:a="http://schemas.openxmlformats.org/drawingml/2006/main" xmlns:r="http://schemas.openxmlformats.org/officeDocument/2006/relationships" xmlns:p="http://schemas.openxmlformats.org/presentationml/2006/main">
+  <p:cSld>
+    <p:spTree>
+      <p:nvGrpSpPr>
+        <p:cNvPr id="1" name=""/>
+        <p:cNvGrpSpPr/>
+        <p:nvPr/>
+      </p:nvGrpSpPr>
+      <p:grpSpPr>
+        <a:xfrm>
+          <a:off x="0" y="0"/>
+          <a:ext cx="0" cy="0"/>
+          <a:chOff x="0" y="0"/>
+          <a:chExt cx="0" cy="0"/>
+        </a:xfrm>
+      </p:grpSpPr>
+      <p:sp>
+        <p:nvSpPr>
+          <p:cNvPr id="2" name="Slide Image Placeholder 1"/>
+          <p:cNvSpPr>
+            <a:spLocks noGrp="1" noRot="1" noChangeAspect="1"/>
+          </p:cNvSpPr>
+          <p:nvPr>
+            <p:ph type="sldImg"/>
+          </p:nvPr>
+        </p:nvSpPr>
+        <p:spPr/>
+      </p:sp>
+      <p:sp>
+        <p:nvSpPr>
+          <p:cNvPr id="3" name="Notes Placeholder 2"/>
+          <p:cNvSpPr>
+            <a:spLocks noGrp="1"/>
+          </p:cNvSpPr>
+          <p:nvPr>
+            <p:ph type="body" idx="1"/>
+          </p:nvPr>
+        </p:nvSpPr>
+        <p:spPr/>
+        <p:txBody>
+          <a:bodyPr/>
+          <a:lstStyle/>
+          <a:p>
+            <a:r>
+              <a:rPr lang="en-US" dirty="0"/>
+              <a:t/>
+            </a:r>
+            <a:endParaRPr lang="en-US" dirty="0"/>
+          </a:p>
+        </p:txBody>
+      </p:sp>
+      <p:sp>
+        <p:nvSpPr>
+          <p:cNvPr id="4" name="Slide Number Placeholder 3"/>
+          <p:cNvSpPr>
+            <a:spLocks noGrp="1"/>
+          </p:cNvSpPr>
+          <p:nvPr>
+            <p:ph type="sldNum" sz="quarter" idx="10"/>
+          </p:nvPr>
+        </p:nvSpPr>
+        <p:spPr/>
+        <p:txBody>
+          <a:bodyPr/>
+          <a:lstStyle/>
+          <a:p>
+            <a:fld id="{F7021451-1387-4CA6-816F-3879F97B5CBC}" type="slidenum">
+              <a:rPr lang="en-US"/>
+              <a:t>6</a:t>
+            </a:fld>
+            <a:endParaRPr lang="en-US"/>
+          </a:p>
+        </p:txBody>
+      </p:sp>
+    </p:spTree>
+    <p:extLst>
+      <p:ext uri="{BB962C8B-B14F-4D97-AF65-F5344CB8AC3E}">
+        <p14:creationId xmlns:p14="http://schemas.microsoft.com/office/powerpoint/2010/main" val="1024086991"/>
+      </p:ext>
+    </p:extLst>
+  </p:cSld>
+  <p:clrMapOvr>
+    <a:masterClrMapping/>
+  </p:clrMapOvr>
+</p:notes>
+</file>
+
 <file path=ppt/slideLayouts/slideLayout1.xml><?xml version="1.0" encoding="utf-8"?>
 <p:sldLayout xmlns:a="http://schemas.openxmlformats.org/drawingml/2006/main" xmlns:r="http://schemas.openxmlformats.org/officeDocument/2006/relationships" xmlns:p="http://schemas.openxmlformats.org/presentationml/2006/main" preserve="1">
   <p:cSld name="DEFAULT">
@@ -1151,7 +1329,7 @@
         <p:spPr>
           <a:xfrm>
             <a:off x="731520" y="1828800"/>
-            <a:ext cx="10515600" cy="1371600"/>
+            <a:ext cx="10515600" cy="1097280"/>
           </a:xfrm>
           <a:prstGeom prst="rect">
             <a:avLst/>
@@ -1167,14 +1345,14 @@
               <a:buNone/>
             </a:pPr>
             <a:r>
-              <a:rPr lang="en-US" sz="3400" b="1" dirty="0">
+              <a:rPr lang="en-US" sz="3800" b="1" dirty="0">
                 <a:solidFill>
                   <a:srgbClr val="FFFFFF"/>
                 </a:solidFill>
               </a:rPr>
-              <a:t>AI Study Assistant - Comprehensive Revision Guide</a:t>
-            </a:r>
-            <a:endParaRPr lang="en-US" sz="3400" dirty="0"/>
+              <a:t>🧠 AI Study Assistant</a:t>
+            </a:r>
+            <a:endParaRPr lang="en-US" sz="3800" dirty="0"/>
           </a:p>
         </p:txBody>
       </p:sp>
@@ -1186,7 +1364,7 @@
         </p:nvSpPr>
         <p:spPr>
           <a:xfrm>
-            <a:off x="731520" y="3291840"/>
+            <a:off x="731520" y="3108960"/>
             <a:ext cx="10515600" cy="548640"/>
           </a:xfrm>
           <a:prstGeom prst="rect">
@@ -1203,14 +1381,14 @@
               <a:buNone/>
             </a:pPr>
             <a:r>
-              <a:rPr lang="en-US" sz="1800" dirty="0">
+              <a:rPr lang="en-US" sz="2000" dirty="0">
                 <a:solidFill>
                   <a:srgbClr val="A5B4FC"/>
                 </a:solidFill>
               </a:rPr>
-              <a:t>Easy-to-Study Summary &amp; PowerPoint Slide Deck</a:t>
-            </a:r>
-            <a:endParaRPr lang="en-US" sz="1800" dirty="0"/>
+              <a:t>Visual Mind Map &amp; Revision Breakdown</a:t>
+            </a:r>
+            <a:endParaRPr lang="en-US" sz="2000" dirty="0"/>
           </a:p>
         </p:txBody>
       </p:sp>
@@ -1244,7 +1422,7 @@
                   <a:srgbClr val="818CF8"/>
                 </a:solidFill>
               </a:rPr>
-              <a:t>Clear English Summary • AI Study Assistant</a:t>
+              <a:t>Easy-to-Study Diagrammatic Summary • Clear English</a:t>
             </a:r>
             <a:endParaRPr lang="en-US" sz="1200" dirty="0"/>
           </a:p>
@@ -1291,7 +1469,7 @@
         <p:spPr>
           <a:xfrm>
             <a:off x="0" y="0"/>
-            <a:ext cx="12188952" cy="914400"/>
+            <a:ext cx="12188952" cy="822960"/>
           </a:xfrm>
           <a:prstGeom prst="rect">
             <a:avLst/>
@@ -1310,7 +1488,7 @@
         </p:nvSpPr>
         <p:spPr>
           <a:xfrm>
-            <a:off x="731520" y="182880"/>
+            <a:off x="731520" y="137160"/>
             <a:ext cx="9144000" cy="548640"/>
           </a:xfrm>
           <a:prstGeom prst="rect">
@@ -1332,7 +1510,7 @@
                   <a:srgbClr val="FFFFFF"/>
                 </a:solidFill>
               </a:rPr>
-              <a:t>Key Revision Concepts</a:t>
+              <a:t>Master Mind Map Overview</a:t>
             </a:r>
             <a:endParaRPr lang="en-US" sz="2200" dirty="0"/>
           </a:p>
@@ -1346,18 +1524,18 @@
         </p:nvSpPr>
         <p:spPr>
           <a:xfrm>
-            <a:off x="731520" y="1188720"/>
-            <a:ext cx="10725912" cy="1051560"/>
+            <a:off x="4718304" y="2926080"/>
+            <a:ext cx="2743200" cy="1097280"/>
           </a:xfrm>
           <a:prstGeom prst="roundRect">
             <a:avLst/>
           </a:prstGeom>
           <a:solidFill>
-            <a:srgbClr val="FFFFFF"/>
-          </a:solidFill>
-          <a:ln w="12700">
+            <a:srgbClr val="4F46E5"/>
+          </a:solidFill>
+          <a:ln w="25400">
             <a:solidFill>
-              <a:srgbClr val="E2E8F0"/>
+              <a:srgbClr val="FFFFFF"/>
             </a:solidFill>
             <a:prstDash val="solid"/>
           </a:ln>
@@ -1365,34 +1543,14 @@
       </p:sp>
       <p:sp>
         <p:nvSpPr>
-          <p:cNvPr id="5" name="Shape 3"/>
-          <p:cNvSpPr/>
-          <p:nvPr/>
-        </p:nvSpPr>
-        <p:spPr>
-          <a:xfrm>
-            <a:off x="1005840" y="1444752"/>
-            <a:ext cx="548640" cy="548640"/>
-          </a:xfrm>
-          <a:prstGeom prst="ellipse">
-            <a:avLst/>
-          </a:prstGeom>
-          <a:solidFill>
-            <a:srgbClr val="4F46E5"/>
-          </a:solidFill>
-          <a:ln/>
-        </p:spPr>
-      </p:sp>
-      <p:sp>
-        <p:nvSpPr>
-          <p:cNvPr id="6" name="Text 4"/>
-          <p:cNvSpPr/>
-          <p:nvPr/>
-        </p:nvSpPr>
-        <p:spPr>
-          <a:xfrm>
-            <a:off x="1005840" y="1444752"/>
-            <a:ext cx="548640" cy="548640"/>
+          <p:cNvPr id="5" name="Text 3"/>
+          <p:cNvSpPr/>
+          <p:nvPr/>
+        </p:nvSpPr>
+        <p:spPr>
+          <a:xfrm>
+            <a:off x="4718304" y="2926080"/>
+            <a:ext cx="2743200" cy="1097280"/>
           </a:xfrm>
           <a:prstGeom prst="rect">
             <a:avLst/>
@@ -1408,63 +1566,41 @@
               <a:buNone/>
             </a:pPr>
             <a:r>
-              <a:rPr lang="en-US" sz="1400" b="1" dirty="0">
+              <a:rPr lang="en-US" sz="1600" b="1" dirty="0">
                 <a:solidFill>
                   <a:srgbClr val="FFFFFF"/>
                 </a:solidFill>
               </a:rPr>
-              <a:t>1</a:t>
-            </a:r>
-            <a:endParaRPr lang="en-US" sz="1400" dirty="0"/>
-          </a:p>
-        </p:txBody>
-      </p:sp>
-      <p:sp>
-        <p:nvSpPr>
-          <p:cNvPr id="7" name="Text 5"/>
-          <p:cNvSpPr/>
-          <p:nvPr/>
-        </p:nvSpPr>
-        <p:spPr>
-          <a:xfrm>
-            <a:off x="1737360" y="1325880"/>
-            <a:ext cx="9418320" cy="777240"/>
-          </a:xfrm>
-          <a:prstGeom prst="rect">
-            <a:avLst/>
-          </a:prstGeom>
-          <a:noFill/>
-          <a:ln/>
-        </p:spPr>
-        <p:txBody>
-          <a:bodyPr wrap="square" rtlCol="0" anchor="ctr"/>
-          <a:lstStyle/>
-          <a:p>
-            <a:pPr indent="0" marL="0">
-              <a:buNone/>
-            </a:pPr>
-            <a:r>
-              <a:rPr lang="en-US" sz="1400" dirty="0">
-                <a:solidFill>
-                  <a:srgbClr val="0F172A"/>
-                </a:solidFill>
-              </a:rPr>
-              <a:t>AI-Powered Note Synthesis: Automatically transforms dense PDF textbooks and lecture slides into clean, bite-sized revision points.</a:t>
-            </a:r>
-            <a:endParaRPr lang="en-US" sz="1400" dirty="0"/>
-          </a:p>
-        </p:txBody>
-      </p:sp>
-      <p:sp>
-        <p:nvSpPr>
-          <p:cNvPr id="8" name="Shape 6"/>
-          <p:cNvSpPr/>
-          <p:nvPr/>
-        </p:nvSpPr>
-        <p:spPr>
-          <a:xfrm>
-            <a:off x="731520" y="2423160"/>
-            <a:ext cx="10725912" cy="1051560"/>
+              <a:t>AI STUDY</a:t>
+            </a:r>
+            <a:endParaRPr lang="en-US" sz="1600" dirty="0"/>
+          </a:p>
+          <a:p>
+            <a:pPr algn="ctr" indent="0" marL="0">
+              <a:buNone/>
+            </a:pPr>
+            <a:r>
+              <a:rPr lang="en-US" sz="1600" b="1" dirty="0">
+                <a:solidFill>
+                  <a:srgbClr val="FFFFFF"/>
+                </a:solidFill>
+              </a:rPr>
+              <a:t>ASSISTANT</a:t>
+            </a:r>
+            <a:endParaRPr lang="en-US" sz="1600" dirty="0"/>
+          </a:p>
+        </p:txBody>
+      </p:sp>
+      <p:sp>
+        <p:nvSpPr>
+          <p:cNvPr id="6" name="Shape 4"/>
+          <p:cNvSpPr/>
+          <p:nvPr/>
+        </p:nvSpPr>
+        <p:spPr>
+          <a:xfrm>
+            <a:off x="731520" y="1097280"/>
+            <a:ext cx="3657600" cy="2286000"/>
           </a:xfrm>
           <a:prstGeom prst="roundRect">
             <a:avLst/>
@@ -1472,9 +1608,9 @@
           <a:solidFill>
             <a:srgbClr val="FFFFFF"/>
           </a:solidFill>
-          <a:ln w="12700">
+          <a:ln w="25400">
             <a:solidFill>
-              <a:srgbClr val="E2E8F0"/>
+              <a:srgbClr val="F43F5E"/>
             </a:solidFill>
             <a:prstDash val="solid"/>
           </a:ln>
@@ -1482,20 +1618,76 @@
       </p:sp>
       <p:sp>
         <p:nvSpPr>
+          <p:cNvPr id="7" name="Shape 5"/>
+          <p:cNvSpPr/>
+          <p:nvPr/>
+        </p:nvSpPr>
+        <p:spPr>
+          <a:xfrm>
+            <a:off x="731520" y="1097280"/>
+            <a:ext cx="3657600" cy="457200"/>
+          </a:xfrm>
+          <a:prstGeom prst="roundRect">
+            <a:avLst/>
+          </a:prstGeom>
+          <a:solidFill>
+            <a:srgbClr val="F43F5E"/>
+          </a:solidFill>
+          <a:ln/>
+        </p:spPr>
+      </p:sp>
+      <p:sp>
+        <p:nvSpPr>
+          <p:cNvPr id="8" name="Text 6"/>
+          <p:cNvSpPr/>
+          <p:nvPr/>
+        </p:nvSpPr>
+        <p:spPr>
+          <a:xfrm>
+            <a:off x="822960" y="1097280"/>
+            <a:ext cx="3474720" cy="457200"/>
+          </a:xfrm>
+          <a:prstGeom prst="rect">
+            <a:avLst/>
+          </a:prstGeom>
+          <a:noFill/>
+          <a:ln/>
+        </p:spPr>
+        <p:txBody>
+          <a:bodyPr wrap="square" rtlCol="0" anchor="ctr"/>
+          <a:lstStyle/>
+          <a:p>
+            <a:pPr indent="0" marL="0">
+              <a:buNone/>
+            </a:pPr>
+            <a:r>
+              <a:rPr lang="en-US" sz="1300" b="1" dirty="0">
+                <a:solidFill>
+                  <a:srgbClr val="FFFFFF"/>
+                </a:solidFill>
+              </a:rPr>
+              <a:t>1. Input &amp; Processing</a:t>
+            </a:r>
+            <a:endParaRPr lang="en-US" sz="1300" dirty="0"/>
+          </a:p>
+        </p:txBody>
+      </p:sp>
+      <p:sp>
+        <p:nvSpPr>
           <p:cNvPr id="9" name="Shape 7"/>
           <p:cNvSpPr/>
           <p:nvPr/>
         </p:nvSpPr>
         <p:spPr>
           <a:xfrm>
-            <a:off x="1005840" y="2679192"/>
-            <a:ext cx="548640" cy="548640"/>
+            <a:off x="914400" y="1783080"/>
+            <a:ext cx="137160" cy="137160"/>
           </a:xfrm>
           <a:prstGeom prst="ellipse">
             <a:avLst/>
           </a:prstGeom>
           <a:solidFill>
-            <a:srgbClr val="4F46E5"/>
+            <a:srgbClr val="F43F5E"/>
           </a:solidFill>
           <a:ln/>
         </p:spPr>
@@ -1508,44 +1700,8 @@
         </p:nvSpPr>
         <p:spPr>
           <a:xfrm>
-            <a:off x="1005840" y="2679192"/>
-            <a:ext cx="548640" cy="548640"/>
-          </a:xfrm>
-          <a:prstGeom prst="rect">
-            <a:avLst/>
-          </a:prstGeom>
-          <a:noFill/>
-          <a:ln/>
-        </p:spPr>
-        <p:txBody>
-          <a:bodyPr wrap="square" rtlCol="0" anchor="ctr"/>
-          <a:lstStyle/>
-          <a:p>
-            <a:pPr algn="ctr" indent="0" marL="0">
-              <a:buNone/>
-            </a:pPr>
-            <a:r>
-              <a:rPr lang="en-US" sz="1400" b="1" dirty="0">
-                <a:solidFill>
-                  <a:srgbClr val="FFFFFF"/>
-                </a:solidFill>
-              </a:rPr>
-              <a:t>2</a:t>
-            </a:r>
-            <a:endParaRPr lang="en-US" sz="1400" dirty="0"/>
-          </a:p>
-        </p:txBody>
-      </p:sp>
-      <p:sp>
-        <p:nvSpPr>
-          <p:cNvPr id="11" name="Text 9"/>
-          <p:cNvSpPr/>
-          <p:nvPr/>
-        </p:nvSpPr>
-        <p:spPr>
-          <a:xfrm>
-            <a:off x="1737360" y="2560320"/>
-            <a:ext cx="9418320" cy="777240"/>
+            <a:off x="1143000" y="1691640"/>
+            <a:ext cx="3154680" cy="502920"/>
           </a:xfrm>
           <a:prstGeom prst="rect">
             <a:avLst/>
@@ -1561,27 +1717,139 @@
               <a:buNone/>
             </a:pPr>
             <a:r>
-              <a:rPr lang="en-US" sz="1400" dirty="0">
-                <a:solidFill>
-                  <a:srgbClr val="0F172A"/>
-                </a:solidFill>
-              </a:rPr>
-              <a:t>Active Recall &amp; Self-Testing: Generates flashcards and MCQ quizzes engineered to optimize memory retention and exam preparation.</a:t>
-            </a:r>
-            <a:endParaRPr lang="en-US" sz="1400" dirty="0"/>
-          </a:p>
-        </p:txBody>
-      </p:sp>
-      <p:sp>
-        <p:nvSpPr>
-          <p:cNvPr id="12" name="Shape 10"/>
-          <p:cNvSpPr/>
-          <p:nvPr/>
-        </p:nvSpPr>
-        <p:spPr>
-          <a:xfrm>
-            <a:off x="731520" y="3657600"/>
-            <a:ext cx="10725912" cy="1051560"/>
+              <a:rPr lang="en-US" sz="1000" dirty="0">
+                <a:solidFill>
+                  <a:srgbClr val="1E293B"/>
+                </a:solidFill>
+              </a:rPr>
+              <a:t>PDF Note Upload (Lectures &amp; Textbooks)</a:t>
+            </a:r>
+            <a:endParaRPr lang="en-US" sz="1000" dirty="0"/>
+          </a:p>
+        </p:txBody>
+      </p:sp>
+      <p:sp>
+        <p:nvSpPr>
+          <p:cNvPr id="11" name="Shape 9"/>
+          <p:cNvSpPr/>
+          <p:nvPr/>
+        </p:nvSpPr>
+        <p:spPr>
+          <a:xfrm>
+            <a:off x="914400" y="2313432"/>
+            <a:ext cx="137160" cy="137160"/>
+          </a:xfrm>
+          <a:prstGeom prst="ellipse">
+            <a:avLst/>
+          </a:prstGeom>
+          <a:solidFill>
+            <a:srgbClr val="F43F5E"/>
+          </a:solidFill>
+          <a:ln/>
+        </p:spPr>
+      </p:sp>
+      <p:sp>
+        <p:nvSpPr>
+          <p:cNvPr id="12" name="Text 10"/>
+          <p:cNvSpPr/>
+          <p:nvPr/>
+        </p:nvSpPr>
+        <p:spPr>
+          <a:xfrm>
+            <a:off x="1143000" y="2221992"/>
+            <a:ext cx="3154680" cy="502920"/>
+          </a:xfrm>
+          <a:prstGeom prst="rect">
+            <a:avLst/>
+          </a:prstGeom>
+          <a:noFill/>
+          <a:ln/>
+        </p:spPr>
+        <p:txBody>
+          <a:bodyPr wrap="square" rtlCol="0" anchor="ctr"/>
+          <a:lstStyle/>
+          <a:p>
+            <a:pPr indent="0" marL="0">
+              <a:buNone/>
+            </a:pPr>
+            <a:r>
+              <a:rPr lang="en-US" sz="1000" dirty="0">
+                <a:solidFill>
+                  <a:srgbClr val="1E293B"/>
+                </a:solidFill>
+              </a:rPr>
+              <a:t>AI Extraction (Gemini / OpenAI API)</a:t>
+            </a:r>
+            <a:endParaRPr lang="en-US" sz="1000" dirty="0"/>
+          </a:p>
+        </p:txBody>
+      </p:sp>
+      <p:sp>
+        <p:nvSpPr>
+          <p:cNvPr id="13" name="Shape 11"/>
+          <p:cNvSpPr/>
+          <p:nvPr/>
+        </p:nvSpPr>
+        <p:spPr>
+          <a:xfrm>
+            <a:off x="914400" y="2843784"/>
+            <a:ext cx="137160" cy="137160"/>
+          </a:xfrm>
+          <a:prstGeom prst="ellipse">
+            <a:avLst/>
+          </a:prstGeom>
+          <a:solidFill>
+            <a:srgbClr val="F43F5E"/>
+          </a:solidFill>
+          <a:ln/>
+        </p:spPr>
+      </p:sp>
+      <p:sp>
+        <p:nvSpPr>
+          <p:cNvPr id="14" name="Text 12"/>
+          <p:cNvSpPr/>
+          <p:nvPr/>
+        </p:nvSpPr>
+        <p:spPr>
+          <a:xfrm>
+            <a:off x="1143000" y="2752344"/>
+            <a:ext cx="3154680" cy="502920"/>
+          </a:xfrm>
+          <a:prstGeom prst="rect">
+            <a:avLst/>
+          </a:prstGeom>
+          <a:noFill/>
+          <a:ln/>
+        </p:spPr>
+        <p:txBody>
+          <a:bodyPr wrap="square" rtlCol="0" anchor="ctr"/>
+          <a:lstStyle/>
+          <a:p>
+            <a:pPr indent="0" marL="0">
+              <a:buNone/>
+            </a:pPr>
+            <a:r>
+              <a:rPr lang="en-US" sz="1000" dirty="0">
+                <a:solidFill>
+                  <a:srgbClr val="1E293B"/>
+                </a:solidFill>
+              </a:rPr>
+              <a:t>Automated Parsing (pdf-parse &amp; Multer)</a:t>
+            </a:r>
+            <a:endParaRPr lang="en-US" sz="1000" dirty="0"/>
+          </a:p>
+        </p:txBody>
+      </p:sp>
+      <p:sp>
+        <p:nvSpPr>
+          <p:cNvPr id="15" name="Shape 13"/>
+          <p:cNvSpPr/>
+          <p:nvPr/>
+        </p:nvSpPr>
+        <p:spPr>
+          <a:xfrm>
+            <a:off x="7799832" y="1097280"/>
+            <a:ext cx="3657600" cy="2286000"/>
           </a:xfrm>
           <a:prstGeom prst="roundRect">
             <a:avLst/>
@@ -1589,9 +1857,9 @@
           <a:solidFill>
             <a:srgbClr val="FFFFFF"/>
           </a:solidFill>
-          <a:ln w="12700">
+          <a:ln w="25400">
             <a:solidFill>
-              <a:srgbClr val="E2E8F0"/>
+              <a:srgbClr val="10B981"/>
             </a:solidFill>
             <a:prstDash val="solid"/>
           </a:ln>
@@ -1599,70 +1867,90 @@
       </p:sp>
       <p:sp>
         <p:nvSpPr>
-          <p:cNvPr id="13" name="Shape 11"/>
-          <p:cNvSpPr/>
-          <p:nvPr/>
-        </p:nvSpPr>
-        <p:spPr>
-          <a:xfrm>
-            <a:off x="1005840" y="3913632"/>
-            <a:ext cx="548640" cy="548640"/>
+          <p:cNvPr id="16" name="Shape 14"/>
+          <p:cNvSpPr/>
+          <p:nvPr/>
+        </p:nvSpPr>
+        <p:spPr>
+          <a:xfrm>
+            <a:off x="7799832" y="1097280"/>
+            <a:ext cx="3657600" cy="457200"/>
+          </a:xfrm>
+          <a:prstGeom prst="roundRect">
+            <a:avLst/>
+          </a:prstGeom>
+          <a:solidFill>
+            <a:srgbClr val="10B981"/>
+          </a:solidFill>
+          <a:ln/>
+        </p:spPr>
+      </p:sp>
+      <p:sp>
+        <p:nvSpPr>
+          <p:cNvPr id="17" name="Text 15"/>
+          <p:cNvSpPr/>
+          <p:nvPr/>
+        </p:nvSpPr>
+        <p:spPr>
+          <a:xfrm>
+            <a:off x="7891272" y="1097280"/>
+            <a:ext cx="3474720" cy="457200"/>
+          </a:xfrm>
+          <a:prstGeom prst="rect">
+            <a:avLst/>
+          </a:prstGeom>
+          <a:noFill/>
+          <a:ln/>
+        </p:spPr>
+        <p:txBody>
+          <a:bodyPr wrap="square" rtlCol="0" anchor="ctr"/>
+          <a:lstStyle/>
+          <a:p>
+            <a:pPr indent="0" marL="0">
+              <a:buNone/>
+            </a:pPr>
+            <a:r>
+              <a:rPr lang="en-US" sz="1300" b="1" dirty="0">
+                <a:solidFill>
+                  <a:srgbClr val="FFFFFF"/>
+                </a:solidFill>
+              </a:rPr>
+              <a:t>2. Core Study Aids</a:t>
+            </a:r>
+            <a:endParaRPr lang="en-US" sz="1300" dirty="0"/>
+          </a:p>
+        </p:txBody>
+      </p:sp>
+      <p:sp>
+        <p:nvSpPr>
+          <p:cNvPr id="18" name="Shape 16"/>
+          <p:cNvSpPr/>
+          <p:nvPr/>
+        </p:nvSpPr>
+        <p:spPr>
+          <a:xfrm>
+            <a:off x="7982712" y="1783080"/>
+            <a:ext cx="137160" cy="137160"/>
           </a:xfrm>
           <a:prstGeom prst="ellipse">
             <a:avLst/>
           </a:prstGeom>
           <a:solidFill>
-            <a:srgbClr val="4F46E5"/>
-          </a:solidFill>
-          <a:ln/>
-        </p:spPr>
-      </p:sp>
-      <p:sp>
-        <p:nvSpPr>
-          <p:cNvPr id="14" name="Text 12"/>
-          <p:cNvSpPr/>
-          <p:nvPr/>
-        </p:nvSpPr>
-        <p:spPr>
-          <a:xfrm>
-            <a:off x="1005840" y="3913632"/>
-            <a:ext cx="548640" cy="548640"/>
-          </a:xfrm>
-          <a:prstGeom prst="rect">
-            <a:avLst/>
-          </a:prstGeom>
-          <a:noFill/>
-          <a:ln/>
-        </p:spPr>
-        <p:txBody>
-          <a:bodyPr wrap="square" rtlCol="0" anchor="ctr"/>
-          <a:lstStyle/>
-          <a:p>
-            <a:pPr algn="ctr" indent="0" marL="0">
-              <a:buNone/>
-            </a:pPr>
-            <a:r>
-              <a:rPr lang="en-US" sz="1400" b="1" dirty="0">
-                <a:solidFill>
-                  <a:srgbClr val="FFFFFF"/>
-                </a:solidFill>
-              </a:rPr>
-              <a:t>3</a:t>
-            </a:r>
-            <a:endParaRPr lang="en-US" sz="1400" dirty="0"/>
-          </a:p>
-        </p:txBody>
-      </p:sp>
-      <p:sp>
-        <p:nvSpPr>
-          <p:cNvPr id="15" name="Text 13"/>
-          <p:cNvSpPr/>
-          <p:nvPr/>
-        </p:nvSpPr>
-        <p:spPr>
-          <a:xfrm>
-            <a:off x="1737360" y="3794760"/>
-            <a:ext cx="9418320" cy="777240"/>
+            <a:srgbClr val="10B981"/>
+          </a:solidFill>
+          <a:ln/>
+        </p:spPr>
+      </p:sp>
+      <p:sp>
+        <p:nvSpPr>
+          <p:cNvPr id="19" name="Text 17"/>
+          <p:cNvSpPr/>
+          <p:nvPr/>
+        </p:nvSpPr>
+        <p:spPr>
+          <a:xfrm>
+            <a:off x="8211312" y="1691640"/>
+            <a:ext cx="3154680" cy="502920"/>
           </a:xfrm>
           <a:prstGeom prst="rect">
             <a:avLst/>
@@ -1678,27 +1966,139 @@
               <a:buNone/>
             </a:pPr>
             <a:r>
-              <a:rPr lang="en-US" sz="1400" dirty="0">
-                <a:solidFill>
-                  <a:srgbClr val="0F172A"/>
-                </a:solidFill>
-              </a:rPr>
-              <a:t>Structured Knowledge Breakdown: Groups complex subject matter into clear definitions, key formulas, and exam-focused takeaways.</a:t>
-            </a:r>
-            <a:endParaRPr lang="en-US" sz="1400" dirty="0"/>
-          </a:p>
-        </p:txBody>
-      </p:sp>
-      <p:sp>
-        <p:nvSpPr>
-          <p:cNvPr id="16" name="Shape 14"/>
-          <p:cNvSpPr/>
-          <p:nvPr/>
-        </p:nvSpPr>
-        <p:spPr>
-          <a:xfrm>
-            <a:off x="731520" y="4892040"/>
-            <a:ext cx="10725912" cy="1051560"/>
+              <a:rPr lang="en-US" sz="1000" dirty="0">
+                <a:solidFill>
+                  <a:srgbClr val="1E293B"/>
+                </a:solidFill>
+              </a:rPr>
+              <a:t>Key Concept Summaries (Essential formulas &amp; definitions)</a:t>
+            </a:r>
+            <a:endParaRPr lang="en-US" sz="1000" dirty="0"/>
+          </a:p>
+        </p:txBody>
+      </p:sp>
+      <p:sp>
+        <p:nvSpPr>
+          <p:cNvPr id="20" name="Shape 18"/>
+          <p:cNvSpPr/>
+          <p:nvPr/>
+        </p:nvSpPr>
+        <p:spPr>
+          <a:xfrm>
+            <a:off x="7982712" y="2313432"/>
+            <a:ext cx="137160" cy="137160"/>
+          </a:xfrm>
+          <a:prstGeom prst="ellipse">
+            <a:avLst/>
+          </a:prstGeom>
+          <a:solidFill>
+            <a:srgbClr val="10B981"/>
+          </a:solidFill>
+          <a:ln/>
+        </p:spPr>
+      </p:sp>
+      <p:sp>
+        <p:nvSpPr>
+          <p:cNvPr id="21" name="Text 19"/>
+          <p:cNvSpPr/>
+          <p:nvPr/>
+        </p:nvSpPr>
+        <p:spPr>
+          <a:xfrm>
+            <a:off x="8211312" y="2221992"/>
+            <a:ext cx="3154680" cy="502920"/>
+          </a:xfrm>
+          <a:prstGeom prst="rect">
+            <a:avLst/>
+          </a:prstGeom>
+          <a:noFill/>
+          <a:ln/>
+        </p:spPr>
+        <p:txBody>
+          <a:bodyPr wrap="square" rtlCol="0" anchor="ctr"/>
+          <a:lstStyle/>
+          <a:p>
+            <a:pPr indent="0" marL="0">
+              <a:buNone/>
+            </a:pPr>
+            <a:r>
+              <a:rPr lang="en-US" sz="1000" dirty="0">
+                <a:solidFill>
+                  <a:srgbClr val="1E293B"/>
+                </a:solidFill>
+              </a:rPr>
+              <a:t>Active Recall Flashcards (Q&amp;A pairs)</a:t>
+            </a:r>
+            <a:endParaRPr lang="en-US" sz="1000" dirty="0"/>
+          </a:p>
+        </p:txBody>
+      </p:sp>
+      <p:sp>
+        <p:nvSpPr>
+          <p:cNvPr id="22" name="Shape 20"/>
+          <p:cNvSpPr/>
+          <p:nvPr/>
+        </p:nvSpPr>
+        <p:spPr>
+          <a:xfrm>
+            <a:off x="7982712" y="2843784"/>
+            <a:ext cx="137160" cy="137160"/>
+          </a:xfrm>
+          <a:prstGeom prst="ellipse">
+            <a:avLst/>
+          </a:prstGeom>
+          <a:solidFill>
+            <a:srgbClr val="10B981"/>
+          </a:solidFill>
+          <a:ln/>
+        </p:spPr>
+      </p:sp>
+      <p:sp>
+        <p:nvSpPr>
+          <p:cNvPr id="23" name="Text 21"/>
+          <p:cNvSpPr/>
+          <p:nvPr/>
+        </p:nvSpPr>
+        <p:spPr>
+          <a:xfrm>
+            <a:off x="8211312" y="2752344"/>
+            <a:ext cx="3154680" cy="502920"/>
+          </a:xfrm>
+          <a:prstGeom prst="rect">
+            <a:avLst/>
+          </a:prstGeom>
+          <a:noFill/>
+          <a:ln/>
+        </p:spPr>
+        <p:txBody>
+          <a:bodyPr wrap="square" rtlCol="0" anchor="ctr"/>
+          <a:lstStyle/>
+          <a:p>
+            <a:pPr indent="0" marL="0">
+              <a:buNone/>
+            </a:pPr>
+            <a:r>
+              <a:rPr lang="en-US" sz="1000" dirty="0">
+                <a:solidFill>
+                  <a:srgbClr val="1E293B"/>
+                </a:solidFill>
+              </a:rPr>
+              <a:t>MCQ Quizzes (Multiple choice self-tests)</a:t>
+            </a:r>
+            <a:endParaRPr lang="en-US" sz="1000" dirty="0"/>
+          </a:p>
+        </p:txBody>
+      </p:sp>
+      <p:sp>
+        <p:nvSpPr>
+          <p:cNvPr id="24" name="Shape 22"/>
+          <p:cNvSpPr/>
+          <p:nvPr/>
+        </p:nvSpPr>
+        <p:spPr>
+          <a:xfrm>
+            <a:off x="731520" y="3931920"/>
+            <a:ext cx="3657600" cy="2286000"/>
           </a:xfrm>
           <a:prstGeom prst="roundRect">
             <a:avLst/>
@@ -1706,9 +2106,9 @@
           <a:solidFill>
             <a:srgbClr val="FFFFFF"/>
           </a:solidFill>
-          <a:ln w="12700">
+          <a:ln w="25400">
             <a:solidFill>
-              <a:srgbClr val="E2E8F0"/>
+              <a:srgbClr val="F59E0B"/>
             </a:solidFill>
             <a:prstDash val="solid"/>
           </a:ln>
@@ -1716,70 +2116,339 @@
       </p:sp>
       <p:sp>
         <p:nvSpPr>
-          <p:cNvPr id="17" name="Shape 15"/>
-          <p:cNvSpPr/>
-          <p:nvPr/>
-        </p:nvSpPr>
-        <p:spPr>
-          <a:xfrm>
-            <a:off x="1005840" y="5148072"/>
-            <a:ext cx="548640" cy="548640"/>
+          <p:cNvPr id="25" name="Shape 23"/>
+          <p:cNvSpPr/>
+          <p:nvPr/>
+        </p:nvSpPr>
+        <p:spPr>
+          <a:xfrm>
+            <a:off x="731520" y="3931920"/>
+            <a:ext cx="3657600" cy="457200"/>
+          </a:xfrm>
+          <a:prstGeom prst="roundRect">
+            <a:avLst/>
+          </a:prstGeom>
+          <a:solidFill>
+            <a:srgbClr val="F59E0B"/>
+          </a:solidFill>
+          <a:ln/>
+        </p:spPr>
+      </p:sp>
+      <p:sp>
+        <p:nvSpPr>
+          <p:cNvPr id="26" name="Text 24"/>
+          <p:cNvSpPr/>
+          <p:nvPr/>
+        </p:nvSpPr>
+        <p:spPr>
+          <a:xfrm>
+            <a:off x="822960" y="3931920"/>
+            <a:ext cx="3474720" cy="457200"/>
+          </a:xfrm>
+          <a:prstGeom prst="rect">
+            <a:avLst/>
+          </a:prstGeom>
+          <a:noFill/>
+          <a:ln/>
+        </p:spPr>
+        <p:txBody>
+          <a:bodyPr wrap="square" rtlCol="0" anchor="ctr"/>
+          <a:lstStyle/>
+          <a:p>
+            <a:pPr indent="0" marL="0">
+              <a:buNone/>
+            </a:pPr>
+            <a:r>
+              <a:rPr lang="en-US" sz="1300" b="1" dirty="0">
+                <a:solidFill>
+                  <a:srgbClr val="FFFFFF"/>
+                </a:solidFill>
+              </a:rPr>
+              <a:t>3. Learning Science</a:t>
+            </a:r>
+            <a:endParaRPr lang="en-US" sz="1300" dirty="0"/>
+          </a:p>
+        </p:txBody>
+      </p:sp>
+      <p:sp>
+        <p:nvSpPr>
+          <p:cNvPr id="27" name="Shape 25"/>
+          <p:cNvSpPr/>
+          <p:nvPr/>
+        </p:nvSpPr>
+        <p:spPr>
+          <a:xfrm>
+            <a:off x="914400" y="4617720"/>
+            <a:ext cx="137160" cy="137160"/>
           </a:xfrm>
           <a:prstGeom prst="ellipse">
             <a:avLst/>
           </a:prstGeom>
           <a:solidFill>
-            <a:srgbClr val="4F46E5"/>
-          </a:solidFill>
-          <a:ln/>
-        </p:spPr>
-      </p:sp>
-      <p:sp>
-        <p:nvSpPr>
-          <p:cNvPr id="18" name="Text 16"/>
-          <p:cNvSpPr/>
-          <p:nvPr/>
-        </p:nvSpPr>
-        <p:spPr>
-          <a:xfrm>
-            <a:off x="1005840" y="5148072"/>
-            <a:ext cx="548640" cy="548640"/>
-          </a:xfrm>
-          <a:prstGeom prst="rect">
-            <a:avLst/>
-          </a:prstGeom>
-          <a:noFill/>
-          <a:ln/>
-        </p:spPr>
-        <p:txBody>
-          <a:bodyPr wrap="square" rtlCol="0" anchor="ctr"/>
-          <a:lstStyle/>
-          <a:p>
-            <a:pPr algn="ctr" indent="0" marL="0">
-              <a:buNone/>
-            </a:pPr>
-            <a:r>
-              <a:rPr lang="en-US" sz="1400" b="1" dirty="0">
+            <a:srgbClr val="F59E0B"/>
+          </a:solidFill>
+          <a:ln/>
+        </p:spPr>
+      </p:sp>
+      <p:sp>
+        <p:nvSpPr>
+          <p:cNvPr id="28" name="Text 26"/>
+          <p:cNvSpPr/>
+          <p:nvPr/>
+        </p:nvSpPr>
+        <p:spPr>
+          <a:xfrm>
+            <a:off x="1143000" y="4526280"/>
+            <a:ext cx="3154680" cy="502920"/>
+          </a:xfrm>
+          <a:prstGeom prst="rect">
+            <a:avLst/>
+          </a:prstGeom>
+          <a:noFill/>
+          <a:ln/>
+        </p:spPr>
+        <p:txBody>
+          <a:bodyPr wrap="square" rtlCol="0" anchor="ctr"/>
+          <a:lstStyle/>
+          <a:p>
+            <a:pPr indent="0" marL="0">
+              <a:buNone/>
+            </a:pPr>
+            <a:r>
+              <a:rPr lang="en-US" sz="1000" dirty="0">
+                <a:solidFill>
+                  <a:srgbClr val="1E293B"/>
+                </a:solidFill>
+              </a:rPr>
+              <a:t>Active Recall (Stimulates active memory retrieval)</a:t>
+            </a:r>
+            <a:endParaRPr lang="en-US" sz="1000" dirty="0"/>
+          </a:p>
+        </p:txBody>
+      </p:sp>
+      <p:sp>
+        <p:nvSpPr>
+          <p:cNvPr id="29" name="Shape 27"/>
+          <p:cNvSpPr/>
+          <p:nvPr/>
+        </p:nvSpPr>
+        <p:spPr>
+          <a:xfrm>
+            <a:off x="914400" y="5148072"/>
+            <a:ext cx="137160" cy="137160"/>
+          </a:xfrm>
+          <a:prstGeom prst="ellipse">
+            <a:avLst/>
+          </a:prstGeom>
+          <a:solidFill>
+            <a:srgbClr val="F59E0B"/>
+          </a:solidFill>
+          <a:ln/>
+        </p:spPr>
+      </p:sp>
+      <p:sp>
+        <p:nvSpPr>
+          <p:cNvPr id="30" name="Text 28"/>
+          <p:cNvSpPr/>
+          <p:nvPr/>
+        </p:nvSpPr>
+        <p:spPr>
+          <a:xfrm>
+            <a:off x="1143000" y="5056632"/>
+            <a:ext cx="3154680" cy="502920"/>
+          </a:xfrm>
+          <a:prstGeom prst="rect">
+            <a:avLst/>
+          </a:prstGeom>
+          <a:noFill/>
+          <a:ln/>
+        </p:spPr>
+        <p:txBody>
+          <a:bodyPr wrap="square" rtlCol="0" anchor="ctr"/>
+          <a:lstStyle/>
+          <a:p>
+            <a:pPr indent="0" marL="0">
+              <a:buNone/>
+            </a:pPr>
+            <a:r>
+              <a:rPr lang="en-US" sz="1000" dirty="0">
+                <a:solidFill>
+                  <a:srgbClr val="1E293B"/>
+                </a:solidFill>
+              </a:rPr>
+              <a:t>Spaced Repetition (Combats forgetting curve over time)</a:t>
+            </a:r>
+            <a:endParaRPr lang="en-US" sz="1000" dirty="0"/>
+          </a:p>
+        </p:txBody>
+      </p:sp>
+      <p:sp>
+        <p:nvSpPr>
+          <p:cNvPr id="31" name="Shape 29"/>
+          <p:cNvSpPr/>
+          <p:nvPr/>
+        </p:nvSpPr>
+        <p:spPr>
+          <a:xfrm>
+            <a:off x="914400" y="5678424"/>
+            <a:ext cx="137160" cy="137160"/>
+          </a:xfrm>
+          <a:prstGeom prst="ellipse">
+            <a:avLst/>
+          </a:prstGeom>
+          <a:solidFill>
+            <a:srgbClr val="F59E0B"/>
+          </a:solidFill>
+          <a:ln/>
+        </p:spPr>
+      </p:sp>
+      <p:sp>
+        <p:nvSpPr>
+          <p:cNvPr id="32" name="Text 30"/>
+          <p:cNvSpPr/>
+          <p:nvPr/>
+        </p:nvSpPr>
+        <p:spPr>
+          <a:xfrm>
+            <a:off x="1143000" y="5586984"/>
+            <a:ext cx="3154680" cy="502920"/>
+          </a:xfrm>
+          <a:prstGeom prst="rect">
+            <a:avLst/>
+          </a:prstGeom>
+          <a:noFill/>
+          <a:ln/>
+        </p:spPr>
+        <p:txBody>
+          <a:bodyPr wrap="square" rtlCol="0" anchor="ctr"/>
+          <a:lstStyle/>
+          <a:p>
+            <a:pPr indent="0" marL="0">
+              <a:buNone/>
+            </a:pPr>
+            <a:r>
+              <a:rPr lang="en-US" sz="1000" dirty="0">
+                <a:solidFill>
+                  <a:srgbClr val="1E293B"/>
+                </a:solidFill>
+              </a:rPr>
+              <a:t>Immediate Feedback (Identifies knowledge gaps instantly)</a:t>
+            </a:r>
+            <a:endParaRPr lang="en-US" sz="1000" dirty="0"/>
+          </a:p>
+        </p:txBody>
+      </p:sp>
+      <p:sp>
+        <p:nvSpPr>
+          <p:cNvPr id="33" name="Shape 31"/>
+          <p:cNvSpPr/>
+          <p:nvPr/>
+        </p:nvSpPr>
+        <p:spPr>
+          <a:xfrm>
+            <a:off x="7799832" y="3931920"/>
+            <a:ext cx="3657600" cy="2286000"/>
+          </a:xfrm>
+          <a:prstGeom prst="roundRect">
+            <a:avLst/>
+          </a:prstGeom>
+          <a:solidFill>
+            <a:srgbClr val="FFFFFF"/>
+          </a:solidFill>
+          <a:ln w="25400">
+            <a:solidFill>
+              <a:srgbClr val="06B6D4"/>
+            </a:solidFill>
+            <a:prstDash val="solid"/>
+          </a:ln>
+        </p:spPr>
+      </p:sp>
+      <p:sp>
+        <p:nvSpPr>
+          <p:cNvPr id="34" name="Shape 32"/>
+          <p:cNvSpPr/>
+          <p:nvPr/>
+        </p:nvSpPr>
+        <p:spPr>
+          <a:xfrm>
+            <a:off x="7799832" y="3931920"/>
+            <a:ext cx="3657600" cy="457200"/>
+          </a:xfrm>
+          <a:prstGeom prst="roundRect">
+            <a:avLst/>
+          </a:prstGeom>
+          <a:solidFill>
+            <a:srgbClr val="06B6D4"/>
+          </a:solidFill>
+          <a:ln/>
+        </p:spPr>
+      </p:sp>
+      <p:sp>
+        <p:nvSpPr>
+          <p:cNvPr id="35" name="Text 33"/>
+          <p:cNvSpPr/>
+          <p:nvPr/>
+        </p:nvSpPr>
+        <p:spPr>
+          <a:xfrm>
+            <a:off x="7891272" y="3931920"/>
+            <a:ext cx="3474720" cy="457200"/>
+          </a:xfrm>
+          <a:prstGeom prst="rect">
+            <a:avLst/>
+          </a:prstGeom>
+          <a:noFill/>
+          <a:ln/>
+        </p:spPr>
+        <p:txBody>
+          <a:bodyPr wrap="square" rtlCol="0" anchor="ctr"/>
+          <a:lstStyle/>
+          <a:p>
+            <a:pPr indent="0" marL="0">
+              <a:buNone/>
+            </a:pPr>
+            <a:r>
+              <a:rPr lang="en-US" sz="1300" b="1" dirty="0">
                 <a:solidFill>
                   <a:srgbClr val="FFFFFF"/>
                 </a:solidFill>
               </a:rPr>
-              <a:t>4</a:t>
-            </a:r>
-            <a:endParaRPr lang="en-US" sz="1400" dirty="0"/>
-          </a:p>
-        </p:txBody>
-      </p:sp>
-      <p:sp>
-        <p:nvSpPr>
-          <p:cNvPr id="19" name="Text 17"/>
-          <p:cNvSpPr/>
-          <p:nvPr/>
-        </p:nvSpPr>
-        <p:spPr>
-          <a:xfrm>
-            <a:off x="1737360" y="5029200"/>
-            <a:ext cx="9418320" cy="777240"/>
+              <a:t>4. System Architecture</a:t>
+            </a:r>
+            <a:endParaRPr lang="en-US" sz="1300" dirty="0"/>
+          </a:p>
+        </p:txBody>
+      </p:sp>
+      <p:sp>
+        <p:nvSpPr>
+          <p:cNvPr id="36" name="Shape 34"/>
+          <p:cNvSpPr/>
+          <p:nvPr/>
+        </p:nvSpPr>
+        <p:spPr>
+          <a:xfrm>
+            <a:off x="7982712" y="4617720"/>
+            <a:ext cx="137160" cy="137160"/>
+          </a:xfrm>
+          <a:prstGeom prst="ellipse">
+            <a:avLst/>
+          </a:prstGeom>
+          <a:solidFill>
+            <a:srgbClr val="06B6D4"/>
+          </a:solidFill>
+          <a:ln/>
+        </p:spPr>
+      </p:sp>
+      <p:sp>
+        <p:nvSpPr>
+          <p:cNvPr id="37" name="Text 35"/>
+          <p:cNvSpPr/>
+          <p:nvPr/>
+        </p:nvSpPr>
+        <p:spPr>
+          <a:xfrm>
+            <a:off x="8211312" y="4526280"/>
+            <a:ext cx="3154680" cy="502920"/>
           </a:xfrm>
           <a:prstGeom prst="rect">
             <a:avLst/>
@@ -1795,14 +2464,126 @@
               <a:buNone/>
             </a:pPr>
             <a:r>
-              <a:rPr lang="en-US" sz="1400" dirty="0">
-                <a:solidFill>
-                  <a:srgbClr val="0F172A"/>
-                </a:solidFill>
-              </a:rPr>
-              <a:t>Instant Feedback &amp; Tracking: Interactive quiz modes highlight weak areas immediately so you focus your study time effectively.</a:t>
-            </a:r>
-            <a:endParaRPr lang="en-US" sz="1400" dirty="0"/>
+              <a:rPr lang="en-US" sz="1000" dirty="0">
+                <a:solidFill>
+                  <a:srgbClr val="1E293B"/>
+                </a:solidFill>
+              </a:rPr>
+              <a:t>Frontend: React 19 + Vite + Tailwind CSS</a:t>
+            </a:r>
+            <a:endParaRPr lang="en-US" sz="1000" dirty="0"/>
+          </a:p>
+        </p:txBody>
+      </p:sp>
+      <p:sp>
+        <p:nvSpPr>
+          <p:cNvPr id="38" name="Shape 36"/>
+          <p:cNvSpPr/>
+          <p:nvPr/>
+        </p:nvSpPr>
+        <p:spPr>
+          <a:xfrm>
+            <a:off x="7982712" y="5148072"/>
+            <a:ext cx="137160" cy="137160"/>
+          </a:xfrm>
+          <a:prstGeom prst="ellipse">
+            <a:avLst/>
+          </a:prstGeom>
+          <a:solidFill>
+            <a:srgbClr val="06B6D4"/>
+          </a:solidFill>
+          <a:ln/>
+        </p:spPr>
+      </p:sp>
+      <p:sp>
+        <p:nvSpPr>
+          <p:cNvPr id="39" name="Text 37"/>
+          <p:cNvSpPr/>
+          <p:nvPr/>
+        </p:nvSpPr>
+        <p:spPr>
+          <a:xfrm>
+            <a:off x="8211312" y="5056632"/>
+            <a:ext cx="3154680" cy="502920"/>
+          </a:xfrm>
+          <a:prstGeom prst="rect">
+            <a:avLst/>
+          </a:prstGeom>
+          <a:noFill/>
+          <a:ln/>
+        </p:spPr>
+        <p:txBody>
+          <a:bodyPr wrap="square" rtlCol="0" anchor="ctr"/>
+          <a:lstStyle/>
+          <a:p>
+            <a:pPr indent="0" marL="0">
+              <a:buNone/>
+            </a:pPr>
+            <a:r>
+              <a:rPr lang="en-US" sz="1000" dirty="0">
+                <a:solidFill>
+                  <a:srgbClr val="1E293B"/>
+                </a:solidFill>
+              </a:rPr>
+              <a:t>Backend: Node.js + Express + MongoDB Atlas</a:t>
+            </a:r>
+            <a:endParaRPr lang="en-US" sz="1000" dirty="0"/>
+          </a:p>
+        </p:txBody>
+      </p:sp>
+      <p:sp>
+        <p:nvSpPr>
+          <p:cNvPr id="40" name="Shape 38"/>
+          <p:cNvSpPr/>
+          <p:nvPr/>
+        </p:nvSpPr>
+        <p:spPr>
+          <a:xfrm>
+            <a:off x="7982712" y="5678424"/>
+            <a:ext cx="137160" cy="137160"/>
+          </a:xfrm>
+          <a:prstGeom prst="ellipse">
+            <a:avLst/>
+          </a:prstGeom>
+          <a:solidFill>
+            <a:srgbClr val="06B6D4"/>
+          </a:solidFill>
+          <a:ln/>
+        </p:spPr>
+      </p:sp>
+      <p:sp>
+        <p:nvSpPr>
+          <p:cNvPr id="41" name="Text 39"/>
+          <p:cNvSpPr/>
+          <p:nvPr/>
+        </p:nvSpPr>
+        <p:spPr>
+          <a:xfrm>
+            <a:off x="8211312" y="5586984"/>
+            <a:ext cx="3154680" cy="502920"/>
+          </a:xfrm>
+          <a:prstGeom prst="rect">
+            <a:avLst/>
+          </a:prstGeom>
+          <a:noFill/>
+          <a:ln/>
+        </p:spPr>
+        <p:txBody>
+          <a:bodyPr wrap="square" rtlCol="0" anchor="ctr"/>
+          <a:lstStyle/>
+          <a:p>
+            <a:pPr indent="0" marL="0">
+              <a:buNone/>
+            </a:pPr>
+            <a:r>
+              <a:rPr lang="en-US" sz="1000" dirty="0">
+                <a:solidFill>
+                  <a:srgbClr val="1E293B"/>
+                </a:solidFill>
+              </a:rPr>
+              <a:t>DevOps: Docker Containers + Nginx + GitHub Actions CI/CD</a:t>
+            </a:r>
+            <a:endParaRPr lang="en-US" sz="1000" dirty="0"/>
           </a:p>
         </p:txBody>
       </p:sp>
@@ -1853,7 +2634,7 @@
             <a:avLst/>
           </a:prstGeom>
           <a:solidFill>
-            <a:srgbClr val="312E81"/>
+            <a:srgbClr val="F43F5E"/>
           </a:solidFill>
           <a:ln/>
         </p:spPr>
@@ -1867,7 +2648,7 @@
         <p:spPr>
           <a:xfrm>
             <a:off x="731520" y="182880"/>
-            <a:ext cx="9144000" cy="548640"/>
+            <a:ext cx="10058400" cy="548640"/>
           </a:xfrm>
           <a:prstGeom prst="rect">
             <a:avLst/>
@@ -1888,7 +2669,7 @@
                   <a:srgbClr val="FFFFFF"/>
                 </a:solidFill>
               </a:rPr>
-              <a:t>Revision Flashcards</a:t>
+              <a:t>Mind Map Branch: 1. Input &amp; Processing</a:t>
             </a:r>
             <a:endParaRPr lang="en-US" sz="2200" dirty="0"/>
           </a:p>
@@ -1902,18 +2683,18 @@
         </p:nvSpPr>
         <p:spPr>
           <a:xfrm>
-            <a:off x="731520" y="1188720"/>
-            <a:ext cx="10725912" cy="1097280"/>
+            <a:off x="731520" y="1280160"/>
+            <a:ext cx="3200400" cy="4754880"/>
           </a:xfrm>
           <a:prstGeom prst="roundRect">
             <a:avLst/>
           </a:prstGeom>
           <a:solidFill>
-            <a:srgbClr val="EEF2FF"/>
-          </a:solidFill>
-          <a:ln w="12700">
+            <a:srgbClr val="FFFFFF"/>
+          </a:solidFill>
+          <a:ln w="25400">
             <a:solidFill>
-              <a:srgbClr val="C7D2FE"/>
+              <a:srgbClr val="F43F5E"/>
             </a:solidFill>
             <a:prstDash val="solid"/>
           </a:ln>
@@ -1921,60 +2702,166 @@
       </p:sp>
       <p:sp>
         <p:nvSpPr>
-          <p:cNvPr id="5" name="Text 3"/>
-          <p:cNvSpPr/>
-          <p:nvPr/>
-        </p:nvSpPr>
-        <p:spPr>
-          <a:xfrm>
-            <a:off x="1005840" y="1325880"/>
-            <a:ext cx="10149840" cy="822960"/>
-          </a:xfrm>
-          <a:prstGeom prst="rect">
-            <a:avLst/>
-          </a:prstGeom>
-          <a:noFill/>
-          <a:ln/>
-        </p:spPr>
-        <p:txBody>
-          <a:bodyPr wrap="square" rtlCol="0" anchor="ctr"/>
-          <a:lstStyle/>
-          <a:p>
-            <a:pPr indent="0" marL="0">
-              <a:buNone/>
-            </a:pPr>
-            <a:r>
-              <a:rPr lang="en-US" sz="1500" b="1" dirty="0">
-                <a:solidFill>
-                  <a:srgbClr val="3730A3"/>
-                </a:solidFill>
-              </a:rPr>
-              <a:t>Q: What is Active Recall and why is it effective?</a:t>
-            </a:r>
-            <a:endParaRPr lang="en-US" sz="1500" dirty="0"/>
-          </a:p>
-        </p:txBody>
-      </p:sp>
-      <p:sp>
-        <p:nvSpPr>
-          <p:cNvPr id="6" name="Shape 4"/>
-          <p:cNvSpPr/>
-          <p:nvPr/>
-        </p:nvSpPr>
-        <p:spPr>
-          <a:xfrm>
-            <a:off x="731520" y="2423160"/>
-            <a:ext cx="10725912" cy="1097280"/>
+          <p:cNvPr id="5" name="Shape 3"/>
+          <p:cNvSpPr/>
+          <p:nvPr/>
+        </p:nvSpPr>
+        <p:spPr>
+          <a:xfrm>
+            <a:off x="1645920" y="1645920"/>
+            <a:ext cx="1371600" cy="1371600"/>
+          </a:xfrm>
+          <a:prstGeom prst="ellipse">
+            <a:avLst/>
+          </a:prstGeom>
+          <a:solidFill>
+            <a:srgbClr val="F43F5E"/>
+          </a:solidFill>
+          <a:ln/>
+        </p:spPr>
+      </p:sp>
+      <p:sp>
+        <p:nvSpPr>
+          <p:cNvPr id="6" name="Text 4"/>
+          <p:cNvSpPr/>
+          <p:nvPr/>
+        </p:nvSpPr>
+        <p:spPr>
+          <a:xfrm>
+            <a:off x="1645920" y="1645920"/>
+            <a:ext cx="1371600" cy="1371600"/>
+          </a:xfrm>
+          <a:prstGeom prst="rect">
+            <a:avLst/>
+          </a:prstGeom>
+          <a:noFill/>
+          <a:ln/>
+        </p:spPr>
+        <p:txBody>
+          <a:bodyPr wrap="square" rtlCol="0" anchor="ctr"/>
+          <a:lstStyle/>
+          <a:p>
+            <a:pPr algn="ctr" indent="0" marL="0">
+              <a:buNone/>
+            </a:pPr>
+            <a:r>
+              <a:rPr lang="en-US" sz="1800" b="1" dirty="0">
+                <a:solidFill>
+                  <a:srgbClr val="FFFFFF"/>
+                </a:solidFill>
+              </a:rPr>
+              <a:t>Branch</a:t>
+            </a:r>
+            <a:endParaRPr lang="en-US" sz="1800" dirty="0"/>
+          </a:p>
+          <a:p>
+            <a:pPr algn="ctr" indent="0" marL="0">
+              <a:buNone/>
+            </a:pPr>
+            <a:r>
+              <a:rPr lang="en-US" sz="1800" b="1" dirty="0">
+                <a:solidFill>
+                  <a:srgbClr val="FFFFFF"/>
+                </a:solidFill>
+              </a:rPr>
+              <a:t>01</a:t>
+            </a:r>
+            <a:endParaRPr lang="en-US" sz="1800" dirty="0"/>
+          </a:p>
+        </p:txBody>
+      </p:sp>
+      <p:sp>
+        <p:nvSpPr>
+          <p:cNvPr id="7" name="Text 5"/>
+          <p:cNvSpPr/>
+          <p:nvPr/>
+        </p:nvSpPr>
+        <p:spPr>
+          <a:xfrm>
+            <a:off x="914400" y="3291840"/>
+            <a:ext cx="2834640" cy="914400"/>
+          </a:xfrm>
+          <a:prstGeom prst="rect">
+            <a:avLst/>
+          </a:prstGeom>
+          <a:noFill/>
+          <a:ln/>
+        </p:spPr>
+        <p:txBody>
+          <a:bodyPr wrap="square" rtlCol="0" anchor="ctr"/>
+          <a:lstStyle/>
+          <a:p>
+            <a:pPr algn="ctr" indent="0" marL="0">
+              <a:buNone/>
+            </a:pPr>
+            <a:r>
+              <a:rPr lang="en-US" sz="1800" b="1" dirty="0">
+                <a:solidFill>
+                  <a:srgbClr val="0F172A"/>
+                </a:solidFill>
+              </a:rPr>
+              <a:t>1. Input &amp; Processing</a:t>
+            </a:r>
+            <a:endParaRPr lang="en-US" sz="1800" dirty="0"/>
+          </a:p>
+        </p:txBody>
+      </p:sp>
+      <p:sp>
+        <p:nvSpPr>
+          <p:cNvPr id="8" name="Text 6"/>
+          <p:cNvSpPr/>
+          <p:nvPr/>
+        </p:nvSpPr>
+        <p:spPr>
+          <a:xfrm>
+            <a:off x="914400" y="4389120"/>
+            <a:ext cx="2834640" cy="914400"/>
+          </a:xfrm>
+          <a:prstGeom prst="rect">
+            <a:avLst/>
+          </a:prstGeom>
+          <a:noFill/>
+          <a:ln/>
+        </p:spPr>
+        <p:txBody>
+          <a:bodyPr wrap="square" rtlCol="0" anchor="ctr"/>
+          <a:lstStyle/>
+          <a:p>
+            <a:pPr algn="ctr" indent="0" marL="0">
+              <a:buNone/>
+            </a:pPr>
+            <a:r>
+              <a:rPr lang="en-US" sz="1200" dirty="0">
+                <a:solidFill>
+                  <a:srgbClr val="64748B"/>
+                </a:solidFill>
+              </a:rPr>
+              <a:t>Core revision pillar of the AI Study Assistant.</a:t>
+            </a:r>
+            <a:endParaRPr lang="en-US" sz="1200" dirty="0"/>
+          </a:p>
+        </p:txBody>
+      </p:sp>
+      <p:sp>
+        <p:nvSpPr>
+          <p:cNvPr id="9" name="Shape 7"/>
+          <p:cNvSpPr/>
+          <p:nvPr/>
+        </p:nvSpPr>
+        <p:spPr>
+          <a:xfrm>
+            <a:off x="4297680" y="1280160"/>
+            <a:ext cx="7132320" cy="1325880"/>
           </a:xfrm>
           <a:prstGeom prst="roundRect">
             <a:avLst/>
           </a:prstGeom>
           <a:solidFill>
-            <a:srgbClr val="ECFDF5"/>
+            <a:srgbClr val="FFFFFF"/>
           </a:solidFill>
           <a:ln w="12700">
             <a:solidFill>
-              <a:srgbClr val="A7F3D0"/>
+              <a:srgbClr val="CBD5E1"/>
             </a:solidFill>
             <a:prstDash val="solid"/>
           </a:ln>
@@ -1982,14 +2869,70 @@
       </p:sp>
       <p:sp>
         <p:nvSpPr>
-          <p:cNvPr id="7" name="Text 5"/>
-          <p:cNvSpPr/>
-          <p:nvPr/>
-        </p:nvSpPr>
-        <p:spPr>
-          <a:xfrm>
-            <a:off x="1005840" y="2560320"/>
-            <a:ext cx="10149840" cy="822960"/>
+          <p:cNvPr id="10" name="Shape 8"/>
+          <p:cNvSpPr/>
+          <p:nvPr/>
+        </p:nvSpPr>
+        <p:spPr>
+          <a:xfrm>
+            <a:off x="4297680" y="1280160"/>
+            <a:ext cx="548640" cy="1325880"/>
+          </a:xfrm>
+          <a:prstGeom prst="roundRect">
+            <a:avLst/>
+          </a:prstGeom>
+          <a:solidFill>
+            <a:srgbClr val="F43F5E"/>
+          </a:solidFill>
+          <a:ln/>
+        </p:spPr>
+      </p:sp>
+      <p:sp>
+        <p:nvSpPr>
+          <p:cNvPr id="11" name="Text 9"/>
+          <p:cNvSpPr/>
+          <p:nvPr/>
+        </p:nvSpPr>
+        <p:spPr>
+          <a:xfrm>
+            <a:off x="4297680" y="1280160"/>
+            <a:ext cx="548640" cy="1325880"/>
+          </a:xfrm>
+          <a:prstGeom prst="rect">
+            <a:avLst/>
+          </a:prstGeom>
+          <a:noFill/>
+          <a:ln/>
+        </p:spPr>
+        <p:txBody>
+          <a:bodyPr wrap="square" rtlCol="0" anchor="ctr"/>
+          <a:lstStyle/>
+          <a:p>
+            <a:pPr algn="ctr" indent="0" marL="0">
+              <a:buNone/>
+            </a:pPr>
+            <a:r>
+              <a:rPr lang="en-US" sz="1600" b="1" dirty="0">
+                <a:solidFill>
+                  <a:srgbClr val="FFFFFF"/>
+                </a:solidFill>
+              </a:rPr>
+              <a:t>1</a:t>
+            </a:r>
+            <a:endParaRPr lang="en-US" sz="1600" dirty="0"/>
+          </a:p>
+        </p:txBody>
+      </p:sp>
+      <p:sp>
+        <p:nvSpPr>
+          <p:cNvPr id="12" name="Text 10"/>
+          <p:cNvSpPr/>
+          <p:nvPr/>
+        </p:nvSpPr>
+        <p:spPr>
+          <a:xfrm>
+            <a:off x="5029200" y="1371600"/>
+            <a:ext cx="6217920" cy="1143000"/>
           </a:xfrm>
           <a:prstGeom prst="rect">
             <a:avLst/>
@@ -2005,37 +2948,37 @@
               <a:buNone/>
             </a:pPr>
             <a:r>
-              <a:rPr lang="en-US" sz="1400" dirty="0">
-                <a:solidFill>
-                  <a:srgbClr val="065F46"/>
-                </a:solidFill>
-              </a:rPr>
-              <a:t>A: Active Recall is a learning method where you retrieve information from memory without looking at notes. It builds stronger neural pathways and dramatically improves retention.</a:t>
-            </a:r>
-            <a:endParaRPr lang="en-US" sz="1400" dirty="0"/>
-          </a:p>
-        </p:txBody>
-      </p:sp>
-      <p:sp>
-        <p:nvSpPr>
-          <p:cNvPr id="8" name="Shape 6"/>
-          <p:cNvSpPr/>
-          <p:nvPr/>
-        </p:nvSpPr>
-        <p:spPr>
-          <a:xfrm>
-            <a:off x="731520" y="3749040"/>
-            <a:ext cx="10725912" cy="1097280"/>
+              <a:rPr lang="en-US" sz="1500" b="1" dirty="0">
+                <a:solidFill>
+                  <a:srgbClr val="1E293B"/>
+                </a:solidFill>
+              </a:rPr>
+              <a:t>PDF Note Upload (Lectures &amp; Textbooks)</a:t>
+            </a:r>
+            <a:endParaRPr lang="en-US" sz="1500" dirty="0"/>
+          </a:p>
+        </p:txBody>
+      </p:sp>
+      <p:sp>
+        <p:nvSpPr>
+          <p:cNvPr id="13" name="Shape 11"/>
+          <p:cNvSpPr/>
+          <p:nvPr/>
+        </p:nvSpPr>
+        <p:spPr>
+          <a:xfrm>
+            <a:off x="4297680" y="2788920"/>
+            <a:ext cx="7132320" cy="1325880"/>
           </a:xfrm>
           <a:prstGeom prst="roundRect">
             <a:avLst/>
           </a:prstGeom>
           <a:solidFill>
-            <a:srgbClr val="EEF2FF"/>
+            <a:srgbClr val="FFFFFF"/>
           </a:solidFill>
           <a:ln w="12700">
             <a:solidFill>
-              <a:srgbClr val="C7D2FE"/>
+              <a:srgbClr val="CBD5E1"/>
             </a:solidFill>
             <a:prstDash val="solid"/>
           </a:ln>
@@ -2043,14 +2986,70 @@
       </p:sp>
       <p:sp>
         <p:nvSpPr>
-          <p:cNvPr id="9" name="Text 7"/>
-          <p:cNvSpPr/>
-          <p:nvPr/>
-        </p:nvSpPr>
-        <p:spPr>
-          <a:xfrm>
-            <a:off x="1005840" y="3886200"/>
-            <a:ext cx="10149840" cy="822960"/>
+          <p:cNvPr id="14" name="Shape 12"/>
+          <p:cNvSpPr/>
+          <p:nvPr/>
+        </p:nvSpPr>
+        <p:spPr>
+          <a:xfrm>
+            <a:off x="4297680" y="2788920"/>
+            <a:ext cx="548640" cy="1325880"/>
+          </a:xfrm>
+          <a:prstGeom prst="roundRect">
+            <a:avLst/>
+          </a:prstGeom>
+          <a:solidFill>
+            <a:srgbClr val="F43F5E"/>
+          </a:solidFill>
+          <a:ln/>
+        </p:spPr>
+      </p:sp>
+      <p:sp>
+        <p:nvSpPr>
+          <p:cNvPr id="15" name="Text 13"/>
+          <p:cNvSpPr/>
+          <p:nvPr/>
+        </p:nvSpPr>
+        <p:spPr>
+          <a:xfrm>
+            <a:off x="4297680" y="2788920"/>
+            <a:ext cx="548640" cy="1325880"/>
+          </a:xfrm>
+          <a:prstGeom prst="rect">
+            <a:avLst/>
+          </a:prstGeom>
+          <a:noFill/>
+          <a:ln/>
+        </p:spPr>
+        <p:txBody>
+          <a:bodyPr wrap="square" rtlCol="0" anchor="ctr"/>
+          <a:lstStyle/>
+          <a:p>
+            <a:pPr algn="ctr" indent="0" marL="0">
+              <a:buNone/>
+            </a:pPr>
+            <a:r>
+              <a:rPr lang="en-US" sz="1600" b="1" dirty="0">
+                <a:solidFill>
+                  <a:srgbClr val="FFFFFF"/>
+                </a:solidFill>
+              </a:rPr>
+              <a:t>2</a:t>
+            </a:r>
+            <a:endParaRPr lang="en-US" sz="1600" dirty="0"/>
+          </a:p>
+        </p:txBody>
+      </p:sp>
+      <p:sp>
+        <p:nvSpPr>
+          <p:cNvPr id="16" name="Text 14"/>
+          <p:cNvSpPr/>
+          <p:nvPr/>
+        </p:nvSpPr>
+        <p:spPr>
+          <a:xfrm>
+            <a:off x="5029200" y="2880360"/>
+            <a:ext cx="6217920" cy="1143000"/>
           </a:xfrm>
           <a:prstGeom prst="rect">
             <a:avLst/>
@@ -2068,10 +3067,10 @@
             <a:r>
               <a:rPr lang="en-US" sz="1500" b="1" dirty="0">
                 <a:solidFill>
-                  <a:srgbClr val="3730A3"/>
-                </a:solidFill>
-              </a:rPr>
-              <a:t>Q: What are the three core study modules provided by the system?</a:t>
+                  <a:srgbClr val="1E293B"/>
+                </a:solidFill>
+              </a:rPr>
+              <a:t>AI Extraction (Gemini / OpenAI API)</a:t>
             </a:r>
             <a:endParaRPr lang="en-US" sz="1500" dirty="0"/>
           </a:p>
@@ -2079,24 +3078,24 @@
       </p:sp>
       <p:sp>
         <p:nvSpPr>
-          <p:cNvPr id="10" name="Shape 8"/>
-          <p:cNvSpPr/>
-          <p:nvPr/>
-        </p:nvSpPr>
-        <p:spPr>
-          <a:xfrm>
-            <a:off x="731520" y="4983480"/>
-            <a:ext cx="10725912" cy="1097280"/>
+          <p:cNvPr id="17" name="Shape 15"/>
+          <p:cNvSpPr/>
+          <p:nvPr/>
+        </p:nvSpPr>
+        <p:spPr>
+          <a:xfrm>
+            <a:off x="4297680" y="4297680"/>
+            <a:ext cx="7132320" cy="1325880"/>
           </a:xfrm>
           <a:prstGeom prst="roundRect">
             <a:avLst/>
           </a:prstGeom>
           <a:solidFill>
-            <a:srgbClr val="ECFDF5"/>
+            <a:srgbClr val="FFFFFF"/>
           </a:solidFill>
           <a:ln w="12700">
             <a:solidFill>
-              <a:srgbClr val="A7F3D0"/>
+              <a:srgbClr val="CBD5E1"/>
             </a:solidFill>
             <a:prstDash val="solid"/>
           </a:ln>
@@ -2104,14 +3103,70 @@
       </p:sp>
       <p:sp>
         <p:nvSpPr>
-          <p:cNvPr id="11" name="Text 9"/>
-          <p:cNvSpPr/>
-          <p:nvPr/>
-        </p:nvSpPr>
-        <p:spPr>
-          <a:xfrm>
-            <a:off x="1005840" y="5120640"/>
-            <a:ext cx="10149840" cy="822960"/>
+          <p:cNvPr id="18" name="Shape 16"/>
+          <p:cNvSpPr/>
+          <p:nvPr/>
+        </p:nvSpPr>
+        <p:spPr>
+          <a:xfrm>
+            <a:off x="4297680" y="4297680"/>
+            <a:ext cx="548640" cy="1325880"/>
+          </a:xfrm>
+          <a:prstGeom prst="roundRect">
+            <a:avLst/>
+          </a:prstGeom>
+          <a:solidFill>
+            <a:srgbClr val="F43F5E"/>
+          </a:solidFill>
+          <a:ln/>
+        </p:spPr>
+      </p:sp>
+      <p:sp>
+        <p:nvSpPr>
+          <p:cNvPr id="19" name="Text 17"/>
+          <p:cNvSpPr/>
+          <p:nvPr/>
+        </p:nvSpPr>
+        <p:spPr>
+          <a:xfrm>
+            <a:off x="4297680" y="4297680"/>
+            <a:ext cx="548640" cy="1325880"/>
+          </a:xfrm>
+          <a:prstGeom prst="rect">
+            <a:avLst/>
+          </a:prstGeom>
+          <a:noFill/>
+          <a:ln/>
+        </p:spPr>
+        <p:txBody>
+          <a:bodyPr wrap="square" rtlCol="0" anchor="ctr"/>
+          <a:lstStyle/>
+          <a:p>
+            <a:pPr algn="ctr" indent="0" marL="0">
+              <a:buNone/>
+            </a:pPr>
+            <a:r>
+              <a:rPr lang="en-US" sz="1600" b="1" dirty="0">
+                <a:solidFill>
+                  <a:srgbClr val="FFFFFF"/>
+                </a:solidFill>
+              </a:rPr>
+              <a:t>3</a:t>
+            </a:r>
+            <a:endParaRPr lang="en-US" sz="1600" dirty="0"/>
+          </a:p>
+        </p:txBody>
+      </p:sp>
+      <p:sp>
+        <p:nvSpPr>
+          <p:cNvPr id="20" name="Text 18"/>
+          <p:cNvSpPr/>
+          <p:nvPr/>
+        </p:nvSpPr>
+        <p:spPr>
+          <a:xfrm>
+            <a:off x="5029200" y="4389120"/>
+            <a:ext cx="6217920" cy="1143000"/>
           </a:xfrm>
           <a:prstGeom prst="rect">
             <a:avLst/>
@@ -2127,14 +3182,14 @@
               <a:buNone/>
             </a:pPr>
             <a:r>
-              <a:rPr lang="en-US" sz="1400" dirty="0">
-                <a:solidFill>
-                  <a:srgbClr val="065F46"/>
-                </a:solidFill>
-              </a:rPr>
-              <a:t>A: 1) Key Concept Summaries for quick overview, 2) Flashcards for active recall, and 3) MCQ Quizzes for self-assessment.</a:t>
-            </a:r>
-            <a:endParaRPr lang="en-US" sz="1400" dirty="0"/>
+              <a:rPr lang="en-US" sz="1500" b="1" dirty="0">
+                <a:solidFill>
+                  <a:srgbClr val="1E293B"/>
+                </a:solidFill>
+              </a:rPr>
+              <a:t>Automated Parsing (pdf-parse &amp; Multer)</a:t>
+            </a:r>
+            <a:endParaRPr lang="en-US" sz="1500" dirty="0"/>
           </a:p>
         </p:txBody>
       </p:sp>
@@ -2185,7 +3240,7 @@
             <a:avLst/>
           </a:prstGeom>
           <a:solidFill>
-            <a:srgbClr val="065F46"/>
+            <a:srgbClr val="10B981"/>
           </a:solidFill>
           <a:ln/>
         </p:spPr>
@@ -2199,7 +3254,7 @@
         <p:spPr>
           <a:xfrm>
             <a:off x="731520" y="182880"/>
-            <a:ext cx="9144000" cy="548640"/>
+            <a:ext cx="10058400" cy="548640"/>
           </a:xfrm>
           <a:prstGeom prst="rect">
             <a:avLst/>
@@ -2220,7 +3275,7 @@
                   <a:srgbClr val="FFFFFF"/>
                 </a:solidFill>
               </a:rPr>
-              <a:t>Self-Assessment Quiz</a:t>
+              <a:t>Mind Map Branch: 2. Core Study Aids</a:t>
             </a:r>
             <a:endParaRPr lang="en-US" sz="2200" dirty="0"/>
           </a:p>
@@ -2228,35 +3283,130 @@
       </p:sp>
       <p:sp>
         <p:nvSpPr>
-          <p:cNvPr id="4" name="Text 2"/>
-          <p:cNvSpPr/>
-          <p:nvPr/>
-        </p:nvSpPr>
-        <p:spPr>
-          <a:xfrm>
-            <a:off x="731520" y="1097280"/>
-            <a:ext cx="10725912" cy="822960"/>
-          </a:xfrm>
-          <a:prstGeom prst="rect">
-            <a:avLst/>
-          </a:prstGeom>
-          <a:noFill/>
-          <a:ln/>
-        </p:spPr>
-        <p:txBody>
-          <a:bodyPr wrap="square" rtlCol="0" anchor="ctr"/>
-          <a:lstStyle/>
-          <a:p>
-            <a:pPr indent="0" marL="0">
+          <p:cNvPr id="4" name="Shape 2"/>
+          <p:cNvSpPr/>
+          <p:nvPr/>
+        </p:nvSpPr>
+        <p:spPr>
+          <a:xfrm>
+            <a:off x="731520" y="1280160"/>
+            <a:ext cx="3200400" cy="4754880"/>
+          </a:xfrm>
+          <a:prstGeom prst="roundRect">
+            <a:avLst/>
+          </a:prstGeom>
+          <a:solidFill>
+            <a:srgbClr val="FFFFFF"/>
+          </a:solidFill>
+          <a:ln w="25400">
+            <a:solidFill>
+              <a:srgbClr val="10B981"/>
+            </a:solidFill>
+            <a:prstDash val="solid"/>
+          </a:ln>
+        </p:spPr>
+      </p:sp>
+      <p:sp>
+        <p:nvSpPr>
+          <p:cNvPr id="5" name="Shape 3"/>
+          <p:cNvSpPr/>
+          <p:nvPr/>
+        </p:nvSpPr>
+        <p:spPr>
+          <a:xfrm>
+            <a:off x="1645920" y="1645920"/>
+            <a:ext cx="1371600" cy="1371600"/>
+          </a:xfrm>
+          <a:prstGeom prst="ellipse">
+            <a:avLst/>
+          </a:prstGeom>
+          <a:solidFill>
+            <a:srgbClr val="10B981"/>
+          </a:solidFill>
+          <a:ln/>
+        </p:spPr>
+      </p:sp>
+      <p:sp>
+        <p:nvSpPr>
+          <p:cNvPr id="6" name="Text 4"/>
+          <p:cNvSpPr/>
+          <p:nvPr/>
+        </p:nvSpPr>
+        <p:spPr>
+          <a:xfrm>
+            <a:off x="1645920" y="1645920"/>
+            <a:ext cx="1371600" cy="1371600"/>
+          </a:xfrm>
+          <a:prstGeom prst="rect">
+            <a:avLst/>
+          </a:prstGeom>
+          <a:noFill/>
+          <a:ln/>
+        </p:spPr>
+        <p:txBody>
+          <a:bodyPr wrap="square" rtlCol="0" anchor="ctr"/>
+          <a:lstStyle/>
+          <a:p>
+            <a:pPr algn="ctr" indent="0" marL="0">
               <a:buNone/>
             </a:pPr>
             <a:r>
               <a:rPr lang="en-US" sz="1800" b="1" dirty="0">
                 <a:solidFill>
+                  <a:srgbClr val="FFFFFF"/>
+                </a:solidFill>
+              </a:rPr>
+              <a:t>Branch</a:t>
+            </a:r>
+            <a:endParaRPr lang="en-US" sz="1800" dirty="0"/>
+          </a:p>
+          <a:p>
+            <a:pPr algn="ctr" indent="0" marL="0">
+              <a:buNone/>
+            </a:pPr>
+            <a:r>
+              <a:rPr lang="en-US" sz="1800" b="1" dirty="0">
+                <a:solidFill>
+                  <a:srgbClr val="FFFFFF"/>
+                </a:solidFill>
+              </a:rPr>
+              <a:t>02</a:t>
+            </a:r>
+            <a:endParaRPr lang="en-US" sz="1800" dirty="0"/>
+          </a:p>
+        </p:txBody>
+      </p:sp>
+      <p:sp>
+        <p:nvSpPr>
+          <p:cNvPr id="7" name="Text 5"/>
+          <p:cNvSpPr/>
+          <p:nvPr/>
+        </p:nvSpPr>
+        <p:spPr>
+          <a:xfrm>
+            <a:off x="914400" y="3291840"/>
+            <a:ext cx="2834640" cy="914400"/>
+          </a:xfrm>
+          <a:prstGeom prst="rect">
+            <a:avLst/>
+          </a:prstGeom>
+          <a:noFill/>
+          <a:ln/>
+        </p:spPr>
+        <p:txBody>
+          <a:bodyPr wrap="square" rtlCol="0" anchor="ctr"/>
+          <a:lstStyle/>
+          <a:p>
+            <a:pPr algn="ctr" indent="0" marL="0">
+              <a:buNone/>
+            </a:pPr>
+            <a:r>
+              <a:rPr lang="en-US" sz="1800" b="1" dirty="0">
+                <a:solidFill>
                   <a:srgbClr val="0F172A"/>
                 </a:solidFill>
               </a:rPr>
-              <a:t>1. Which studying technique provides the highest long-term retention rate?</a:t>
+              <a:t>2. Core Study Aids</a:t>
             </a:r>
             <a:endParaRPr lang="en-US" sz="1800" dirty="0"/>
           </a:p>
@@ -2264,14 +3414,50 @@
       </p:sp>
       <p:sp>
         <p:nvSpPr>
-          <p:cNvPr id="5" name="Shape 3"/>
-          <p:cNvSpPr/>
-          <p:nvPr/>
-        </p:nvSpPr>
-        <p:spPr>
-          <a:xfrm>
-            <a:off x="731520" y="2011680"/>
-            <a:ext cx="10725912" cy="777240"/>
+          <p:cNvPr id="8" name="Text 6"/>
+          <p:cNvSpPr/>
+          <p:nvPr/>
+        </p:nvSpPr>
+        <p:spPr>
+          <a:xfrm>
+            <a:off x="914400" y="4389120"/>
+            <a:ext cx="2834640" cy="914400"/>
+          </a:xfrm>
+          <a:prstGeom prst="rect">
+            <a:avLst/>
+          </a:prstGeom>
+          <a:noFill/>
+          <a:ln/>
+        </p:spPr>
+        <p:txBody>
+          <a:bodyPr wrap="square" rtlCol="0" anchor="ctr"/>
+          <a:lstStyle/>
+          <a:p>
+            <a:pPr algn="ctr" indent="0" marL="0">
+              <a:buNone/>
+            </a:pPr>
+            <a:r>
+              <a:rPr lang="en-US" sz="1200" dirty="0">
+                <a:solidFill>
+                  <a:srgbClr val="64748B"/>
+                </a:solidFill>
+              </a:rPr>
+              <a:t>Core revision pillar of the AI Study Assistant.</a:t>
+            </a:r>
+            <a:endParaRPr lang="en-US" sz="1200" dirty="0"/>
+          </a:p>
+        </p:txBody>
+      </p:sp>
+      <p:sp>
+        <p:nvSpPr>
+          <p:cNvPr id="9" name="Shape 7"/>
+          <p:cNvSpPr/>
+          <p:nvPr/>
+        </p:nvSpPr>
+        <p:spPr>
+          <a:xfrm>
+            <a:off x="4297680" y="1280160"/>
+            <a:ext cx="7132320" cy="1325880"/>
           </a:xfrm>
           <a:prstGeom prst="roundRect">
             <a:avLst/>
@@ -2289,14 +3475,70 @@
       </p:sp>
       <p:sp>
         <p:nvSpPr>
-          <p:cNvPr id="6" name="Text 4"/>
-          <p:cNvSpPr/>
-          <p:nvPr/>
-        </p:nvSpPr>
-        <p:spPr>
-          <a:xfrm>
-            <a:off x="1097280" y="2103120"/>
-            <a:ext cx="10058400" cy="594360"/>
+          <p:cNvPr id="10" name="Shape 8"/>
+          <p:cNvSpPr/>
+          <p:nvPr/>
+        </p:nvSpPr>
+        <p:spPr>
+          <a:xfrm>
+            <a:off x="4297680" y="1280160"/>
+            <a:ext cx="548640" cy="1325880"/>
+          </a:xfrm>
+          <a:prstGeom prst="roundRect">
+            <a:avLst/>
+          </a:prstGeom>
+          <a:solidFill>
+            <a:srgbClr val="10B981"/>
+          </a:solidFill>
+          <a:ln/>
+        </p:spPr>
+      </p:sp>
+      <p:sp>
+        <p:nvSpPr>
+          <p:cNvPr id="11" name="Text 9"/>
+          <p:cNvSpPr/>
+          <p:nvPr/>
+        </p:nvSpPr>
+        <p:spPr>
+          <a:xfrm>
+            <a:off x="4297680" y="1280160"/>
+            <a:ext cx="548640" cy="1325880"/>
+          </a:xfrm>
+          <a:prstGeom prst="rect">
+            <a:avLst/>
+          </a:prstGeom>
+          <a:noFill/>
+          <a:ln/>
+        </p:spPr>
+        <p:txBody>
+          <a:bodyPr wrap="square" rtlCol="0" anchor="ctr"/>
+          <a:lstStyle/>
+          <a:p>
+            <a:pPr algn="ctr" indent="0" marL="0">
+              <a:buNone/>
+            </a:pPr>
+            <a:r>
+              <a:rPr lang="en-US" sz="1600" b="1" dirty="0">
+                <a:solidFill>
+                  <a:srgbClr val="FFFFFF"/>
+                </a:solidFill>
+              </a:rPr>
+              <a:t>1</a:t>
+            </a:r>
+            <a:endParaRPr lang="en-US" sz="1600" dirty="0"/>
+          </a:p>
+        </p:txBody>
+      </p:sp>
+      <p:sp>
+        <p:nvSpPr>
+          <p:cNvPr id="12" name="Text 10"/>
+          <p:cNvSpPr/>
+          <p:nvPr/>
+        </p:nvSpPr>
+        <p:spPr>
+          <a:xfrm>
+            <a:off x="5029200" y="1371600"/>
+            <a:ext cx="6217920" cy="1143000"/>
           </a:xfrm>
           <a:prstGeom prst="rect">
             <a:avLst/>
@@ -2312,88 +3554,27 @@
               <a:buNone/>
             </a:pPr>
             <a:r>
-              <a:rPr lang="en-US" sz="1400" dirty="0">
-                <a:solidFill>
-                  <a:srgbClr val="334155"/>
-                </a:solidFill>
-              </a:rPr>
-              <a:t>A. Passive re-reading of textbook chapters </a:t>
-            </a:r>
-            <a:endParaRPr lang="en-US" sz="1400" dirty="0"/>
-          </a:p>
-        </p:txBody>
-      </p:sp>
-      <p:sp>
-        <p:nvSpPr>
-          <p:cNvPr id="7" name="Shape 5"/>
-          <p:cNvSpPr/>
-          <p:nvPr/>
-        </p:nvSpPr>
-        <p:spPr>
-          <a:xfrm>
-            <a:off x="731520" y="2926080"/>
-            <a:ext cx="10725912" cy="777240"/>
-          </a:xfrm>
-          <a:prstGeom prst="roundRect">
-            <a:avLst/>
-          </a:prstGeom>
-          <a:solidFill>
-            <a:srgbClr val="D1FAE5"/>
-          </a:solidFill>
-          <a:ln w="25400">
-            <a:solidFill>
-              <a:srgbClr val="10B981"/>
-            </a:solidFill>
-            <a:prstDash val="solid"/>
-          </a:ln>
-        </p:spPr>
-      </p:sp>
-      <p:sp>
-        <p:nvSpPr>
-          <p:cNvPr id="8" name="Text 6"/>
-          <p:cNvSpPr/>
-          <p:nvPr/>
-        </p:nvSpPr>
-        <p:spPr>
-          <a:xfrm>
-            <a:off x="1097280" y="3017520"/>
-            <a:ext cx="10058400" cy="594360"/>
-          </a:xfrm>
-          <a:prstGeom prst="rect">
-            <a:avLst/>
-          </a:prstGeom>
-          <a:noFill/>
-          <a:ln/>
-        </p:spPr>
-        <p:txBody>
-          <a:bodyPr wrap="square" rtlCol="0" anchor="ctr"/>
-          <a:lstStyle/>
-          <a:p>
-            <a:pPr indent="0" marL="0">
-              <a:buNone/>
-            </a:pPr>
-            <a:r>
-              <a:rPr lang="en-US" sz="1400" b="1" dirty="0">
-                <a:solidFill>
-                  <a:srgbClr val="047857"/>
-                </a:solidFill>
-              </a:rPr>
-              <a:t>B. Active recall and self-testing  (Correct Answer ✓)</a:t>
-            </a:r>
-            <a:endParaRPr lang="en-US" sz="1400" dirty="0"/>
-          </a:p>
-        </p:txBody>
-      </p:sp>
-      <p:sp>
-        <p:nvSpPr>
-          <p:cNvPr id="9" name="Shape 7"/>
-          <p:cNvSpPr/>
-          <p:nvPr/>
-        </p:nvSpPr>
-        <p:spPr>
-          <a:xfrm>
-            <a:off x="731520" y="3840480"/>
-            <a:ext cx="10725912" cy="777240"/>
+              <a:rPr lang="en-US" sz="1500" b="1" dirty="0">
+                <a:solidFill>
+                  <a:srgbClr val="1E293B"/>
+                </a:solidFill>
+              </a:rPr>
+              <a:t>Key Concept Summaries (Essential formulas &amp; definitions)</a:t>
+            </a:r>
+            <a:endParaRPr lang="en-US" sz="1500" dirty="0"/>
+          </a:p>
+        </p:txBody>
+      </p:sp>
+      <p:sp>
+        <p:nvSpPr>
+          <p:cNvPr id="13" name="Shape 11"/>
+          <p:cNvSpPr/>
+          <p:nvPr/>
+        </p:nvSpPr>
+        <p:spPr>
+          <a:xfrm>
+            <a:off x="4297680" y="2788920"/>
+            <a:ext cx="7132320" cy="1325880"/>
           </a:xfrm>
           <a:prstGeom prst="roundRect">
             <a:avLst/>
@@ -2411,14 +3592,70 @@
       </p:sp>
       <p:sp>
         <p:nvSpPr>
-          <p:cNvPr id="10" name="Text 8"/>
-          <p:cNvSpPr/>
-          <p:nvPr/>
-        </p:nvSpPr>
-        <p:spPr>
-          <a:xfrm>
-            <a:off x="1097280" y="3931920"/>
-            <a:ext cx="10058400" cy="594360"/>
+          <p:cNvPr id="14" name="Shape 12"/>
+          <p:cNvSpPr/>
+          <p:nvPr/>
+        </p:nvSpPr>
+        <p:spPr>
+          <a:xfrm>
+            <a:off x="4297680" y="2788920"/>
+            <a:ext cx="548640" cy="1325880"/>
+          </a:xfrm>
+          <a:prstGeom prst="roundRect">
+            <a:avLst/>
+          </a:prstGeom>
+          <a:solidFill>
+            <a:srgbClr val="10B981"/>
+          </a:solidFill>
+          <a:ln/>
+        </p:spPr>
+      </p:sp>
+      <p:sp>
+        <p:nvSpPr>
+          <p:cNvPr id="15" name="Text 13"/>
+          <p:cNvSpPr/>
+          <p:nvPr/>
+        </p:nvSpPr>
+        <p:spPr>
+          <a:xfrm>
+            <a:off x="4297680" y="2788920"/>
+            <a:ext cx="548640" cy="1325880"/>
+          </a:xfrm>
+          <a:prstGeom prst="rect">
+            <a:avLst/>
+          </a:prstGeom>
+          <a:noFill/>
+          <a:ln/>
+        </p:spPr>
+        <p:txBody>
+          <a:bodyPr wrap="square" rtlCol="0" anchor="ctr"/>
+          <a:lstStyle/>
+          <a:p>
+            <a:pPr algn="ctr" indent="0" marL="0">
+              <a:buNone/>
+            </a:pPr>
+            <a:r>
+              <a:rPr lang="en-US" sz="1600" b="1" dirty="0">
+                <a:solidFill>
+                  <a:srgbClr val="FFFFFF"/>
+                </a:solidFill>
+              </a:rPr>
+              <a:t>2</a:t>
+            </a:r>
+            <a:endParaRPr lang="en-US" sz="1600" dirty="0"/>
+          </a:p>
+        </p:txBody>
+      </p:sp>
+      <p:sp>
+        <p:nvSpPr>
+          <p:cNvPr id="16" name="Text 14"/>
+          <p:cNvSpPr/>
+          <p:nvPr/>
+        </p:nvSpPr>
+        <p:spPr>
+          <a:xfrm>
+            <a:off x="5029200" y="2880360"/>
+            <a:ext cx="6217920" cy="1143000"/>
           </a:xfrm>
           <a:prstGeom prst="rect">
             <a:avLst/>
@@ -2434,27 +3671,27 @@
               <a:buNone/>
             </a:pPr>
             <a:r>
-              <a:rPr lang="en-US" sz="1400" dirty="0">
-                <a:solidFill>
-                  <a:srgbClr val="334155"/>
-                </a:solidFill>
-              </a:rPr>
-              <a:t>C. Highlighting sentences in notes </a:t>
-            </a:r>
-            <a:endParaRPr lang="en-US" sz="1400" dirty="0"/>
-          </a:p>
-        </p:txBody>
-      </p:sp>
-      <p:sp>
-        <p:nvSpPr>
-          <p:cNvPr id="11" name="Shape 9"/>
-          <p:cNvSpPr/>
-          <p:nvPr/>
-        </p:nvSpPr>
-        <p:spPr>
-          <a:xfrm>
-            <a:off x="731520" y="4754880"/>
-            <a:ext cx="10725912" cy="777240"/>
+              <a:rPr lang="en-US" sz="1500" b="1" dirty="0">
+                <a:solidFill>
+                  <a:srgbClr val="1E293B"/>
+                </a:solidFill>
+              </a:rPr>
+              <a:t>Active Recall Flashcards (Q&amp;A pairs)</a:t>
+            </a:r>
+            <a:endParaRPr lang="en-US" sz="1500" dirty="0"/>
+          </a:p>
+        </p:txBody>
+      </p:sp>
+      <p:sp>
+        <p:nvSpPr>
+          <p:cNvPr id="17" name="Shape 15"/>
+          <p:cNvSpPr/>
+          <p:nvPr/>
+        </p:nvSpPr>
+        <p:spPr>
+          <a:xfrm>
+            <a:off x="4297680" y="4297680"/>
+            <a:ext cx="7132320" cy="1325880"/>
           </a:xfrm>
           <a:prstGeom prst="roundRect">
             <a:avLst/>
@@ -2472,14 +3709,442 @@
       </p:sp>
       <p:sp>
         <p:nvSpPr>
+          <p:cNvPr id="18" name="Shape 16"/>
+          <p:cNvSpPr/>
+          <p:nvPr/>
+        </p:nvSpPr>
+        <p:spPr>
+          <a:xfrm>
+            <a:off x="4297680" y="4297680"/>
+            <a:ext cx="548640" cy="1325880"/>
+          </a:xfrm>
+          <a:prstGeom prst="roundRect">
+            <a:avLst/>
+          </a:prstGeom>
+          <a:solidFill>
+            <a:srgbClr val="10B981"/>
+          </a:solidFill>
+          <a:ln/>
+        </p:spPr>
+      </p:sp>
+      <p:sp>
+        <p:nvSpPr>
+          <p:cNvPr id="19" name="Text 17"/>
+          <p:cNvSpPr/>
+          <p:nvPr/>
+        </p:nvSpPr>
+        <p:spPr>
+          <a:xfrm>
+            <a:off x="4297680" y="4297680"/>
+            <a:ext cx="548640" cy="1325880"/>
+          </a:xfrm>
+          <a:prstGeom prst="rect">
+            <a:avLst/>
+          </a:prstGeom>
+          <a:noFill/>
+          <a:ln/>
+        </p:spPr>
+        <p:txBody>
+          <a:bodyPr wrap="square" rtlCol="0" anchor="ctr"/>
+          <a:lstStyle/>
+          <a:p>
+            <a:pPr algn="ctr" indent="0" marL="0">
+              <a:buNone/>
+            </a:pPr>
+            <a:r>
+              <a:rPr lang="en-US" sz="1600" b="1" dirty="0">
+                <a:solidFill>
+                  <a:srgbClr val="FFFFFF"/>
+                </a:solidFill>
+              </a:rPr>
+              <a:t>3</a:t>
+            </a:r>
+            <a:endParaRPr lang="en-US" sz="1600" dirty="0"/>
+          </a:p>
+        </p:txBody>
+      </p:sp>
+      <p:sp>
+        <p:nvSpPr>
+          <p:cNvPr id="20" name="Text 18"/>
+          <p:cNvSpPr/>
+          <p:nvPr/>
+        </p:nvSpPr>
+        <p:spPr>
+          <a:xfrm>
+            <a:off x="5029200" y="4389120"/>
+            <a:ext cx="6217920" cy="1143000"/>
+          </a:xfrm>
+          <a:prstGeom prst="rect">
+            <a:avLst/>
+          </a:prstGeom>
+          <a:noFill/>
+          <a:ln/>
+        </p:spPr>
+        <p:txBody>
+          <a:bodyPr wrap="square" rtlCol="0" anchor="ctr"/>
+          <a:lstStyle/>
+          <a:p>
+            <a:pPr indent="0" marL="0">
+              <a:buNone/>
+            </a:pPr>
+            <a:r>
+              <a:rPr lang="en-US" sz="1500" b="1" dirty="0">
+                <a:solidFill>
+                  <a:srgbClr val="1E293B"/>
+                </a:solidFill>
+              </a:rPr>
+              <a:t>MCQ Quizzes (Multiple choice self-tests)</a:t>
+            </a:r>
+            <a:endParaRPr lang="en-US" sz="1500" dirty="0"/>
+          </a:p>
+        </p:txBody>
+      </p:sp>
+    </p:spTree>
+  </p:cSld>
+  <p:clrMapOvr>
+    <a:masterClrMapping/>
+  </p:clrMapOvr>
+</p:sld>
+</file>
+
+<file path=ppt/slides/slide5.xml><?xml version="1.0" encoding="utf-8"?>
+<p:sld xmlns:a="http://schemas.openxmlformats.org/drawingml/2006/main" xmlns:r="http://schemas.openxmlformats.org/officeDocument/2006/relationships" xmlns:p="http://schemas.openxmlformats.org/presentationml/2006/main">
+  <p:cSld name="Slide 5">
+    <p:bg>
+      <p:bgPr>
+        <a:solidFill>
+          <a:srgbClr val="F8FAFC"/>
+        </a:solidFill>
+      </p:bgPr>
+    </p:bg>
+    <p:spTree>
+      <p:nvGrpSpPr>
+        <p:cNvPr id="1" name=""/>
+        <p:cNvGrpSpPr/>
+        <p:nvPr/>
+      </p:nvGrpSpPr>
+      <p:grpSpPr>
+        <a:xfrm>
+          <a:off x="0" y="0"/>
+          <a:ext cx="0" cy="0"/>
+          <a:chOff x="0" y="0"/>
+          <a:chExt cx="0" cy="0"/>
+        </a:xfrm>
+      </p:grpSpPr>
+      <p:sp>
+        <p:nvSpPr>
+          <p:cNvPr id="2" name="Shape 0"/>
+          <p:cNvSpPr/>
+          <p:nvPr/>
+        </p:nvSpPr>
+        <p:spPr>
+          <a:xfrm>
+            <a:off x="0" y="0"/>
+            <a:ext cx="12188952" cy="914400"/>
+          </a:xfrm>
+          <a:prstGeom prst="rect">
+            <a:avLst/>
+          </a:prstGeom>
+          <a:solidFill>
+            <a:srgbClr val="F59E0B"/>
+          </a:solidFill>
+          <a:ln/>
+        </p:spPr>
+      </p:sp>
+      <p:sp>
+        <p:nvSpPr>
+          <p:cNvPr id="3" name="Text 1"/>
+          <p:cNvSpPr/>
+          <p:nvPr/>
+        </p:nvSpPr>
+        <p:spPr>
+          <a:xfrm>
+            <a:off x="731520" y="182880"/>
+            <a:ext cx="10058400" cy="548640"/>
+          </a:xfrm>
+          <a:prstGeom prst="rect">
+            <a:avLst/>
+          </a:prstGeom>
+          <a:noFill/>
+          <a:ln/>
+        </p:spPr>
+        <p:txBody>
+          <a:bodyPr wrap="square" rtlCol="0" anchor="ctr"/>
+          <a:lstStyle/>
+          <a:p>
+            <a:pPr indent="0" marL="0">
+              <a:buNone/>
+            </a:pPr>
+            <a:r>
+              <a:rPr lang="en-US" sz="2200" b="1" dirty="0">
+                <a:solidFill>
+                  <a:srgbClr val="FFFFFF"/>
+                </a:solidFill>
+              </a:rPr>
+              <a:t>Mind Map Branch: 3. Learning Science</a:t>
+            </a:r>
+            <a:endParaRPr lang="en-US" sz="2200" dirty="0"/>
+          </a:p>
+        </p:txBody>
+      </p:sp>
+      <p:sp>
+        <p:nvSpPr>
+          <p:cNvPr id="4" name="Shape 2"/>
+          <p:cNvSpPr/>
+          <p:nvPr/>
+        </p:nvSpPr>
+        <p:spPr>
+          <a:xfrm>
+            <a:off x="731520" y="1280160"/>
+            <a:ext cx="3200400" cy="4754880"/>
+          </a:xfrm>
+          <a:prstGeom prst="roundRect">
+            <a:avLst/>
+          </a:prstGeom>
+          <a:solidFill>
+            <a:srgbClr val="FFFFFF"/>
+          </a:solidFill>
+          <a:ln w="25400">
+            <a:solidFill>
+              <a:srgbClr val="F59E0B"/>
+            </a:solidFill>
+            <a:prstDash val="solid"/>
+          </a:ln>
+        </p:spPr>
+      </p:sp>
+      <p:sp>
+        <p:nvSpPr>
+          <p:cNvPr id="5" name="Shape 3"/>
+          <p:cNvSpPr/>
+          <p:nvPr/>
+        </p:nvSpPr>
+        <p:spPr>
+          <a:xfrm>
+            <a:off x="1645920" y="1645920"/>
+            <a:ext cx="1371600" cy="1371600"/>
+          </a:xfrm>
+          <a:prstGeom prst="ellipse">
+            <a:avLst/>
+          </a:prstGeom>
+          <a:solidFill>
+            <a:srgbClr val="F59E0B"/>
+          </a:solidFill>
+          <a:ln/>
+        </p:spPr>
+      </p:sp>
+      <p:sp>
+        <p:nvSpPr>
+          <p:cNvPr id="6" name="Text 4"/>
+          <p:cNvSpPr/>
+          <p:nvPr/>
+        </p:nvSpPr>
+        <p:spPr>
+          <a:xfrm>
+            <a:off x="1645920" y="1645920"/>
+            <a:ext cx="1371600" cy="1371600"/>
+          </a:xfrm>
+          <a:prstGeom prst="rect">
+            <a:avLst/>
+          </a:prstGeom>
+          <a:noFill/>
+          <a:ln/>
+        </p:spPr>
+        <p:txBody>
+          <a:bodyPr wrap="square" rtlCol="0" anchor="ctr"/>
+          <a:lstStyle/>
+          <a:p>
+            <a:pPr algn="ctr" indent="0" marL="0">
+              <a:buNone/>
+            </a:pPr>
+            <a:r>
+              <a:rPr lang="en-US" sz="1800" b="1" dirty="0">
+                <a:solidFill>
+                  <a:srgbClr val="FFFFFF"/>
+                </a:solidFill>
+              </a:rPr>
+              <a:t>Branch</a:t>
+            </a:r>
+            <a:endParaRPr lang="en-US" sz="1800" dirty="0"/>
+          </a:p>
+          <a:p>
+            <a:pPr algn="ctr" indent="0" marL="0">
+              <a:buNone/>
+            </a:pPr>
+            <a:r>
+              <a:rPr lang="en-US" sz="1800" b="1" dirty="0">
+                <a:solidFill>
+                  <a:srgbClr val="FFFFFF"/>
+                </a:solidFill>
+              </a:rPr>
+              <a:t>03</a:t>
+            </a:r>
+            <a:endParaRPr lang="en-US" sz="1800" dirty="0"/>
+          </a:p>
+        </p:txBody>
+      </p:sp>
+      <p:sp>
+        <p:nvSpPr>
+          <p:cNvPr id="7" name="Text 5"/>
+          <p:cNvSpPr/>
+          <p:nvPr/>
+        </p:nvSpPr>
+        <p:spPr>
+          <a:xfrm>
+            <a:off x="914400" y="3291840"/>
+            <a:ext cx="2834640" cy="914400"/>
+          </a:xfrm>
+          <a:prstGeom prst="rect">
+            <a:avLst/>
+          </a:prstGeom>
+          <a:noFill/>
+          <a:ln/>
+        </p:spPr>
+        <p:txBody>
+          <a:bodyPr wrap="square" rtlCol="0" anchor="ctr"/>
+          <a:lstStyle/>
+          <a:p>
+            <a:pPr algn="ctr" indent="0" marL="0">
+              <a:buNone/>
+            </a:pPr>
+            <a:r>
+              <a:rPr lang="en-US" sz="1800" b="1" dirty="0">
+                <a:solidFill>
+                  <a:srgbClr val="0F172A"/>
+                </a:solidFill>
+              </a:rPr>
+              <a:t>3. Learning Science</a:t>
+            </a:r>
+            <a:endParaRPr lang="en-US" sz="1800" dirty="0"/>
+          </a:p>
+        </p:txBody>
+      </p:sp>
+      <p:sp>
+        <p:nvSpPr>
+          <p:cNvPr id="8" name="Text 6"/>
+          <p:cNvSpPr/>
+          <p:nvPr/>
+        </p:nvSpPr>
+        <p:spPr>
+          <a:xfrm>
+            <a:off x="914400" y="4389120"/>
+            <a:ext cx="2834640" cy="914400"/>
+          </a:xfrm>
+          <a:prstGeom prst="rect">
+            <a:avLst/>
+          </a:prstGeom>
+          <a:noFill/>
+          <a:ln/>
+        </p:spPr>
+        <p:txBody>
+          <a:bodyPr wrap="square" rtlCol="0" anchor="ctr"/>
+          <a:lstStyle/>
+          <a:p>
+            <a:pPr algn="ctr" indent="0" marL="0">
+              <a:buNone/>
+            </a:pPr>
+            <a:r>
+              <a:rPr lang="en-US" sz="1200" dirty="0">
+                <a:solidFill>
+                  <a:srgbClr val="64748B"/>
+                </a:solidFill>
+              </a:rPr>
+              <a:t>Core revision pillar of the AI Study Assistant.</a:t>
+            </a:r>
+            <a:endParaRPr lang="en-US" sz="1200" dirty="0"/>
+          </a:p>
+        </p:txBody>
+      </p:sp>
+      <p:sp>
+        <p:nvSpPr>
+          <p:cNvPr id="9" name="Shape 7"/>
+          <p:cNvSpPr/>
+          <p:nvPr/>
+        </p:nvSpPr>
+        <p:spPr>
+          <a:xfrm>
+            <a:off x="4297680" y="1280160"/>
+            <a:ext cx="7132320" cy="1325880"/>
+          </a:xfrm>
+          <a:prstGeom prst="roundRect">
+            <a:avLst/>
+          </a:prstGeom>
+          <a:solidFill>
+            <a:srgbClr val="FFFFFF"/>
+          </a:solidFill>
+          <a:ln w="12700">
+            <a:solidFill>
+              <a:srgbClr val="CBD5E1"/>
+            </a:solidFill>
+            <a:prstDash val="solid"/>
+          </a:ln>
+        </p:spPr>
+      </p:sp>
+      <p:sp>
+        <p:nvSpPr>
+          <p:cNvPr id="10" name="Shape 8"/>
+          <p:cNvSpPr/>
+          <p:nvPr/>
+        </p:nvSpPr>
+        <p:spPr>
+          <a:xfrm>
+            <a:off x="4297680" y="1280160"/>
+            <a:ext cx="548640" cy="1325880"/>
+          </a:xfrm>
+          <a:prstGeom prst="roundRect">
+            <a:avLst/>
+          </a:prstGeom>
+          <a:solidFill>
+            <a:srgbClr val="F59E0B"/>
+          </a:solidFill>
+          <a:ln/>
+        </p:spPr>
+      </p:sp>
+      <p:sp>
+        <p:nvSpPr>
+          <p:cNvPr id="11" name="Text 9"/>
+          <p:cNvSpPr/>
+          <p:nvPr/>
+        </p:nvSpPr>
+        <p:spPr>
+          <a:xfrm>
+            <a:off x="4297680" y="1280160"/>
+            <a:ext cx="548640" cy="1325880"/>
+          </a:xfrm>
+          <a:prstGeom prst="rect">
+            <a:avLst/>
+          </a:prstGeom>
+          <a:noFill/>
+          <a:ln/>
+        </p:spPr>
+        <p:txBody>
+          <a:bodyPr wrap="square" rtlCol="0" anchor="ctr"/>
+          <a:lstStyle/>
+          <a:p>
+            <a:pPr algn="ctr" indent="0" marL="0">
+              <a:buNone/>
+            </a:pPr>
+            <a:r>
+              <a:rPr lang="en-US" sz="1600" b="1" dirty="0">
+                <a:solidFill>
+                  <a:srgbClr val="FFFFFF"/>
+                </a:solidFill>
+              </a:rPr>
+              <a:t>1</a:t>
+            </a:r>
+            <a:endParaRPr lang="en-US" sz="1600" dirty="0"/>
+          </a:p>
+        </p:txBody>
+      </p:sp>
+      <p:sp>
+        <p:nvSpPr>
           <p:cNvPr id="12" name="Text 10"/>
           <p:cNvSpPr/>
           <p:nvPr/>
         </p:nvSpPr>
         <p:spPr>
           <a:xfrm>
-            <a:off x="1097280" y="4846320"/>
-            <a:ext cx="10058400" cy="594360"/>
+            <a:off x="5029200" y="1371600"/>
+            <a:ext cx="6217920" cy="1143000"/>
           </a:xfrm>
           <a:prstGeom prst="rect">
             <a:avLst/>
@@ -2495,14 +4160,854 @@
               <a:buNone/>
             </a:pPr>
             <a:r>
-              <a:rPr lang="en-US" sz="1400" dirty="0">
-                <a:solidFill>
-                  <a:srgbClr val="334155"/>
-                </a:solidFill>
-              </a:rPr>
-              <a:t>D. Copying notes word-for-word </a:t>
-            </a:r>
-            <a:endParaRPr lang="en-US" sz="1400" dirty="0"/>
+              <a:rPr lang="en-US" sz="1500" b="1" dirty="0">
+                <a:solidFill>
+                  <a:srgbClr val="1E293B"/>
+                </a:solidFill>
+              </a:rPr>
+              <a:t>Active Recall (Stimulates active memory retrieval)</a:t>
+            </a:r>
+            <a:endParaRPr lang="en-US" sz="1500" dirty="0"/>
+          </a:p>
+        </p:txBody>
+      </p:sp>
+      <p:sp>
+        <p:nvSpPr>
+          <p:cNvPr id="13" name="Shape 11"/>
+          <p:cNvSpPr/>
+          <p:nvPr/>
+        </p:nvSpPr>
+        <p:spPr>
+          <a:xfrm>
+            <a:off x="4297680" y="2788920"/>
+            <a:ext cx="7132320" cy="1325880"/>
+          </a:xfrm>
+          <a:prstGeom prst="roundRect">
+            <a:avLst/>
+          </a:prstGeom>
+          <a:solidFill>
+            <a:srgbClr val="FFFFFF"/>
+          </a:solidFill>
+          <a:ln w="12700">
+            <a:solidFill>
+              <a:srgbClr val="CBD5E1"/>
+            </a:solidFill>
+            <a:prstDash val="solid"/>
+          </a:ln>
+        </p:spPr>
+      </p:sp>
+      <p:sp>
+        <p:nvSpPr>
+          <p:cNvPr id="14" name="Shape 12"/>
+          <p:cNvSpPr/>
+          <p:nvPr/>
+        </p:nvSpPr>
+        <p:spPr>
+          <a:xfrm>
+            <a:off x="4297680" y="2788920"/>
+            <a:ext cx="548640" cy="1325880"/>
+          </a:xfrm>
+          <a:prstGeom prst="roundRect">
+            <a:avLst/>
+          </a:prstGeom>
+          <a:solidFill>
+            <a:srgbClr val="F59E0B"/>
+          </a:solidFill>
+          <a:ln/>
+        </p:spPr>
+      </p:sp>
+      <p:sp>
+        <p:nvSpPr>
+          <p:cNvPr id="15" name="Text 13"/>
+          <p:cNvSpPr/>
+          <p:nvPr/>
+        </p:nvSpPr>
+        <p:spPr>
+          <a:xfrm>
+            <a:off x="4297680" y="2788920"/>
+            <a:ext cx="548640" cy="1325880"/>
+          </a:xfrm>
+          <a:prstGeom prst="rect">
+            <a:avLst/>
+          </a:prstGeom>
+          <a:noFill/>
+          <a:ln/>
+        </p:spPr>
+        <p:txBody>
+          <a:bodyPr wrap="square" rtlCol="0" anchor="ctr"/>
+          <a:lstStyle/>
+          <a:p>
+            <a:pPr algn="ctr" indent="0" marL="0">
+              <a:buNone/>
+            </a:pPr>
+            <a:r>
+              <a:rPr lang="en-US" sz="1600" b="1" dirty="0">
+                <a:solidFill>
+                  <a:srgbClr val="FFFFFF"/>
+                </a:solidFill>
+              </a:rPr>
+              <a:t>2</a:t>
+            </a:r>
+            <a:endParaRPr lang="en-US" sz="1600" dirty="0"/>
+          </a:p>
+        </p:txBody>
+      </p:sp>
+      <p:sp>
+        <p:nvSpPr>
+          <p:cNvPr id="16" name="Text 14"/>
+          <p:cNvSpPr/>
+          <p:nvPr/>
+        </p:nvSpPr>
+        <p:spPr>
+          <a:xfrm>
+            <a:off x="5029200" y="2880360"/>
+            <a:ext cx="6217920" cy="1143000"/>
+          </a:xfrm>
+          <a:prstGeom prst="rect">
+            <a:avLst/>
+          </a:prstGeom>
+          <a:noFill/>
+          <a:ln/>
+        </p:spPr>
+        <p:txBody>
+          <a:bodyPr wrap="square" rtlCol="0" anchor="ctr"/>
+          <a:lstStyle/>
+          <a:p>
+            <a:pPr indent="0" marL="0">
+              <a:buNone/>
+            </a:pPr>
+            <a:r>
+              <a:rPr lang="en-US" sz="1500" b="1" dirty="0">
+                <a:solidFill>
+                  <a:srgbClr val="1E293B"/>
+                </a:solidFill>
+              </a:rPr>
+              <a:t>Spaced Repetition (Combats forgetting curve over time)</a:t>
+            </a:r>
+            <a:endParaRPr lang="en-US" sz="1500" dirty="0"/>
+          </a:p>
+        </p:txBody>
+      </p:sp>
+      <p:sp>
+        <p:nvSpPr>
+          <p:cNvPr id="17" name="Shape 15"/>
+          <p:cNvSpPr/>
+          <p:nvPr/>
+        </p:nvSpPr>
+        <p:spPr>
+          <a:xfrm>
+            <a:off x="4297680" y="4297680"/>
+            <a:ext cx="7132320" cy="1325880"/>
+          </a:xfrm>
+          <a:prstGeom prst="roundRect">
+            <a:avLst/>
+          </a:prstGeom>
+          <a:solidFill>
+            <a:srgbClr val="FFFFFF"/>
+          </a:solidFill>
+          <a:ln w="12700">
+            <a:solidFill>
+              <a:srgbClr val="CBD5E1"/>
+            </a:solidFill>
+            <a:prstDash val="solid"/>
+          </a:ln>
+        </p:spPr>
+      </p:sp>
+      <p:sp>
+        <p:nvSpPr>
+          <p:cNvPr id="18" name="Shape 16"/>
+          <p:cNvSpPr/>
+          <p:nvPr/>
+        </p:nvSpPr>
+        <p:spPr>
+          <a:xfrm>
+            <a:off x="4297680" y="4297680"/>
+            <a:ext cx="548640" cy="1325880"/>
+          </a:xfrm>
+          <a:prstGeom prst="roundRect">
+            <a:avLst/>
+          </a:prstGeom>
+          <a:solidFill>
+            <a:srgbClr val="F59E0B"/>
+          </a:solidFill>
+          <a:ln/>
+        </p:spPr>
+      </p:sp>
+      <p:sp>
+        <p:nvSpPr>
+          <p:cNvPr id="19" name="Text 17"/>
+          <p:cNvSpPr/>
+          <p:nvPr/>
+        </p:nvSpPr>
+        <p:spPr>
+          <a:xfrm>
+            <a:off x="4297680" y="4297680"/>
+            <a:ext cx="548640" cy="1325880"/>
+          </a:xfrm>
+          <a:prstGeom prst="rect">
+            <a:avLst/>
+          </a:prstGeom>
+          <a:noFill/>
+          <a:ln/>
+        </p:spPr>
+        <p:txBody>
+          <a:bodyPr wrap="square" rtlCol="0" anchor="ctr"/>
+          <a:lstStyle/>
+          <a:p>
+            <a:pPr algn="ctr" indent="0" marL="0">
+              <a:buNone/>
+            </a:pPr>
+            <a:r>
+              <a:rPr lang="en-US" sz="1600" b="1" dirty="0">
+                <a:solidFill>
+                  <a:srgbClr val="FFFFFF"/>
+                </a:solidFill>
+              </a:rPr>
+              <a:t>3</a:t>
+            </a:r>
+            <a:endParaRPr lang="en-US" sz="1600" dirty="0"/>
+          </a:p>
+        </p:txBody>
+      </p:sp>
+      <p:sp>
+        <p:nvSpPr>
+          <p:cNvPr id="20" name="Text 18"/>
+          <p:cNvSpPr/>
+          <p:nvPr/>
+        </p:nvSpPr>
+        <p:spPr>
+          <a:xfrm>
+            <a:off x="5029200" y="4389120"/>
+            <a:ext cx="6217920" cy="1143000"/>
+          </a:xfrm>
+          <a:prstGeom prst="rect">
+            <a:avLst/>
+          </a:prstGeom>
+          <a:noFill/>
+          <a:ln/>
+        </p:spPr>
+        <p:txBody>
+          <a:bodyPr wrap="square" rtlCol="0" anchor="ctr"/>
+          <a:lstStyle/>
+          <a:p>
+            <a:pPr indent="0" marL="0">
+              <a:buNone/>
+            </a:pPr>
+            <a:r>
+              <a:rPr lang="en-US" sz="1500" b="1" dirty="0">
+                <a:solidFill>
+                  <a:srgbClr val="1E293B"/>
+                </a:solidFill>
+              </a:rPr>
+              <a:t>Immediate Feedback (Identifies knowledge gaps instantly)</a:t>
+            </a:r>
+            <a:endParaRPr lang="en-US" sz="1500" dirty="0"/>
+          </a:p>
+        </p:txBody>
+      </p:sp>
+    </p:spTree>
+  </p:cSld>
+  <p:clrMapOvr>
+    <a:masterClrMapping/>
+  </p:clrMapOvr>
+</p:sld>
+</file>
+
+<file path=ppt/slides/slide6.xml><?xml version="1.0" encoding="utf-8"?>
+<p:sld xmlns:a="http://schemas.openxmlformats.org/drawingml/2006/main" xmlns:r="http://schemas.openxmlformats.org/officeDocument/2006/relationships" xmlns:p="http://schemas.openxmlformats.org/presentationml/2006/main">
+  <p:cSld name="Slide 6">
+    <p:bg>
+      <p:bgPr>
+        <a:solidFill>
+          <a:srgbClr val="F8FAFC"/>
+        </a:solidFill>
+      </p:bgPr>
+    </p:bg>
+    <p:spTree>
+      <p:nvGrpSpPr>
+        <p:cNvPr id="1" name=""/>
+        <p:cNvGrpSpPr/>
+        <p:nvPr/>
+      </p:nvGrpSpPr>
+      <p:grpSpPr>
+        <a:xfrm>
+          <a:off x="0" y="0"/>
+          <a:ext cx="0" cy="0"/>
+          <a:chOff x="0" y="0"/>
+          <a:chExt cx="0" cy="0"/>
+        </a:xfrm>
+      </p:grpSpPr>
+      <p:sp>
+        <p:nvSpPr>
+          <p:cNvPr id="2" name="Shape 0"/>
+          <p:cNvSpPr/>
+          <p:nvPr/>
+        </p:nvSpPr>
+        <p:spPr>
+          <a:xfrm>
+            <a:off x="0" y="0"/>
+            <a:ext cx="12188952" cy="914400"/>
+          </a:xfrm>
+          <a:prstGeom prst="rect">
+            <a:avLst/>
+          </a:prstGeom>
+          <a:solidFill>
+            <a:srgbClr val="06B6D4"/>
+          </a:solidFill>
+          <a:ln/>
+        </p:spPr>
+      </p:sp>
+      <p:sp>
+        <p:nvSpPr>
+          <p:cNvPr id="3" name="Text 1"/>
+          <p:cNvSpPr/>
+          <p:nvPr/>
+        </p:nvSpPr>
+        <p:spPr>
+          <a:xfrm>
+            <a:off x="731520" y="182880"/>
+            <a:ext cx="10058400" cy="548640"/>
+          </a:xfrm>
+          <a:prstGeom prst="rect">
+            <a:avLst/>
+          </a:prstGeom>
+          <a:noFill/>
+          <a:ln/>
+        </p:spPr>
+        <p:txBody>
+          <a:bodyPr wrap="square" rtlCol="0" anchor="ctr"/>
+          <a:lstStyle/>
+          <a:p>
+            <a:pPr indent="0" marL="0">
+              <a:buNone/>
+            </a:pPr>
+            <a:r>
+              <a:rPr lang="en-US" sz="2200" b="1" dirty="0">
+                <a:solidFill>
+                  <a:srgbClr val="FFFFFF"/>
+                </a:solidFill>
+              </a:rPr>
+              <a:t>Mind Map Branch: 4. System Architecture</a:t>
+            </a:r>
+            <a:endParaRPr lang="en-US" sz="2200" dirty="0"/>
+          </a:p>
+        </p:txBody>
+      </p:sp>
+      <p:sp>
+        <p:nvSpPr>
+          <p:cNvPr id="4" name="Shape 2"/>
+          <p:cNvSpPr/>
+          <p:nvPr/>
+        </p:nvSpPr>
+        <p:spPr>
+          <a:xfrm>
+            <a:off x="731520" y="1280160"/>
+            <a:ext cx="3200400" cy="4754880"/>
+          </a:xfrm>
+          <a:prstGeom prst="roundRect">
+            <a:avLst/>
+          </a:prstGeom>
+          <a:solidFill>
+            <a:srgbClr val="FFFFFF"/>
+          </a:solidFill>
+          <a:ln w="25400">
+            <a:solidFill>
+              <a:srgbClr val="06B6D4"/>
+            </a:solidFill>
+            <a:prstDash val="solid"/>
+          </a:ln>
+        </p:spPr>
+      </p:sp>
+      <p:sp>
+        <p:nvSpPr>
+          <p:cNvPr id="5" name="Shape 3"/>
+          <p:cNvSpPr/>
+          <p:nvPr/>
+        </p:nvSpPr>
+        <p:spPr>
+          <a:xfrm>
+            <a:off x="1645920" y="1645920"/>
+            <a:ext cx="1371600" cy="1371600"/>
+          </a:xfrm>
+          <a:prstGeom prst="ellipse">
+            <a:avLst/>
+          </a:prstGeom>
+          <a:solidFill>
+            <a:srgbClr val="06B6D4"/>
+          </a:solidFill>
+          <a:ln/>
+        </p:spPr>
+      </p:sp>
+      <p:sp>
+        <p:nvSpPr>
+          <p:cNvPr id="6" name="Text 4"/>
+          <p:cNvSpPr/>
+          <p:nvPr/>
+        </p:nvSpPr>
+        <p:spPr>
+          <a:xfrm>
+            <a:off x="1645920" y="1645920"/>
+            <a:ext cx="1371600" cy="1371600"/>
+          </a:xfrm>
+          <a:prstGeom prst="rect">
+            <a:avLst/>
+          </a:prstGeom>
+          <a:noFill/>
+          <a:ln/>
+        </p:spPr>
+        <p:txBody>
+          <a:bodyPr wrap="square" rtlCol="0" anchor="ctr"/>
+          <a:lstStyle/>
+          <a:p>
+            <a:pPr algn="ctr" indent="0" marL="0">
+              <a:buNone/>
+            </a:pPr>
+            <a:r>
+              <a:rPr lang="en-US" sz="1800" b="1" dirty="0">
+                <a:solidFill>
+                  <a:srgbClr val="FFFFFF"/>
+                </a:solidFill>
+              </a:rPr>
+              <a:t>Branch</a:t>
+            </a:r>
+            <a:endParaRPr lang="en-US" sz="1800" dirty="0"/>
+          </a:p>
+          <a:p>
+            <a:pPr algn="ctr" indent="0" marL="0">
+              <a:buNone/>
+            </a:pPr>
+            <a:r>
+              <a:rPr lang="en-US" sz="1800" b="1" dirty="0">
+                <a:solidFill>
+                  <a:srgbClr val="FFFFFF"/>
+                </a:solidFill>
+              </a:rPr>
+              <a:t>04</a:t>
+            </a:r>
+            <a:endParaRPr lang="en-US" sz="1800" dirty="0"/>
+          </a:p>
+        </p:txBody>
+      </p:sp>
+      <p:sp>
+        <p:nvSpPr>
+          <p:cNvPr id="7" name="Text 5"/>
+          <p:cNvSpPr/>
+          <p:nvPr/>
+        </p:nvSpPr>
+        <p:spPr>
+          <a:xfrm>
+            <a:off x="914400" y="3291840"/>
+            <a:ext cx="2834640" cy="914400"/>
+          </a:xfrm>
+          <a:prstGeom prst="rect">
+            <a:avLst/>
+          </a:prstGeom>
+          <a:noFill/>
+          <a:ln/>
+        </p:spPr>
+        <p:txBody>
+          <a:bodyPr wrap="square" rtlCol="0" anchor="ctr"/>
+          <a:lstStyle/>
+          <a:p>
+            <a:pPr algn="ctr" indent="0" marL="0">
+              <a:buNone/>
+            </a:pPr>
+            <a:r>
+              <a:rPr lang="en-US" sz="1800" b="1" dirty="0">
+                <a:solidFill>
+                  <a:srgbClr val="0F172A"/>
+                </a:solidFill>
+              </a:rPr>
+              <a:t>4. System Architecture</a:t>
+            </a:r>
+            <a:endParaRPr lang="en-US" sz="1800" dirty="0"/>
+          </a:p>
+        </p:txBody>
+      </p:sp>
+      <p:sp>
+        <p:nvSpPr>
+          <p:cNvPr id="8" name="Text 6"/>
+          <p:cNvSpPr/>
+          <p:nvPr/>
+        </p:nvSpPr>
+        <p:spPr>
+          <a:xfrm>
+            <a:off x="914400" y="4389120"/>
+            <a:ext cx="2834640" cy="914400"/>
+          </a:xfrm>
+          <a:prstGeom prst="rect">
+            <a:avLst/>
+          </a:prstGeom>
+          <a:noFill/>
+          <a:ln/>
+        </p:spPr>
+        <p:txBody>
+          <a:bodyPr wrap="square" rtlCol="0" anchor="ctr"/>
+          <a:lstStyle/>
+          <a:p>
+            <a:pPr algn="ctr" indent="0" marL="0">
+              <a:buNone/>
+            </a:pPr>
+            <a:r>
+              <a:rPr lang="en-US" sz="1200" dirty="0">
+                <a:solidFill>
+                  <a:srgbClr val="64748B"/>
+                </a:solidFill>
+              </a:rPr>
+              <a:t>Core revision pillar of the AI Study Assistant.</a:t>
+            </a:r>
+            <a:endParaRPr lang="en-US" sz="1200" dirty="0"/>
+          </a:p>
+        </p:txBody>
+      </p:sp>
+      <p:sp>
+        <p:nvSpPr>
+          <p:cNvPr id="9" name="Shape 7"/>
+          <p:cNvSpPr/>
+          <p:nvPr/>
+        </p:nvSpPr>
+        <p:spPr>
+          <a:xfrm>
+            <a:off x="4297680" y="1280160"/>
+            <a:ext cx="7132320" cy="1325880"/>
+          </a:xfrm>
+          <a:prstGeom prst="roundRect">
+            <a:avLst/>
+          </a:prstGeom>
+          <a:solidFill>
+            <a:srgbClr val="FFFFFF"/>
+          </a:solidFill>
+          <a:ln w="12700">
+            <a:solidFill>
+              <a:srgbClr val="CBD5E1"/>
+            </a:solidFill>
+            <a:prstDash val="solid"/>
+          </a:ln>
+        </p:spPr>
+      </p:sp>
+      <p:sp>
+        <p:nvSpPr>
+          <p:cNvPr id="10" name="Shape 8"/>
+          <p:cNvSpPr/>
+          <p:nvPr/>
+        </p:nvSpPr>
+        <p:spPr>
+          <a:xfrm>
+            <a:off x="4297680" y="1280160"/>
+            <a:ext cx="548640" cy="1325880"/>
+          </a:xfrm>
+          <a:prstGeom prst="roundRect">
+            <a:avLst/>
+          </a:prstGeom>
+          <a:solidFill>
+            <a:srgbClr val="06B6D4"/>
+          </a:solidFill>
+          <a:ln/>
+        </p:spPr>
+      </p:sp>
+      <p:sp>
+        <p:nvSpPr>
+          <p:cNvPr id="11" name="Text 9"/>
+          <p:cNvSpPr/>
+          <p:nvPr/>
+        </p:nvSpPr>
+        <p:spPr>
+          <a:xfrm>
+            <a:off x="4297680" y="1280160"/>
+            <a:ext cx="548640" cy="1325880"/>
+          </a:xfrm>
+          <a:prstGeom prst="rect">
+            <a:avLst/>
+          </a:prstGeom>
+          <a:noFill/>
+          <a:ln/>
+        </p:spPr>
+        <p:txBody>
+          <a:bodyPr wrap="square" rtlCol="0" anchor="ctr"/>
+          <a:lstStyle/>
+          <a:p>
+            <a:pPr algn="ctr" indent="0" marL="0">
+              <a:buNone/>
+            </a:pPr>
+            <a:r>
+              <a:rPr lang="en-US" sz="1600" b="1" dirty="0">
+                <a:solidFill>
+                  <a:srgbClr val="FFFFFF"/>
+                </a:solidFill>
+              </a:rPr>
+              <a:t>1</a:t>
+            </a:r>
+            <a:endParaRPr lang="en-US" sz="1600" dirty="0"/>
+          </a:p>
+        </p:txBody>
+      </p:sp>
+      <p:sp>
+        <p:nvSpPr>
+          <p:cNvPr id="12" name="Text 10"/>
+          <p:cNvSpPr/>
+          <p:nvPr/>
+        </p:nvSpPr>
+        <p:spPr>
+          <a:xfrm>
+            <a:off x="5029200" y="1371600"/>
+            <a:ext cx="6217920" cy="1143000"/>
+          </a:xfrm>
+          <a:prstGeom prst="rect">
+            <a:avLst/>
+          </a:prstGeom>
+          <a:noFill/>
+          <a:ln/>
+        </p:spPr>
+        <p:txBody>
+          <a:bodyPr wrap="square" rtlCol="0" anchor="ctr"/>
+          <a:lstStyle/>
+          <a:p>
+            <a:pPr indent="0" marL="0">
+              <a:buNone/>
+            </a:pPr>
+            <a:r>
+              <a:rPr lang="en-US" sz="1500" b="1" dirty="0">
+                <a:solidFill>
+                  <a:srgbClr val="1E293B"/>
+                </a:solidFill>
+              </a:rPr>
+              <a:t>Frontend: React 19 + Vite + Tailwind CSS</a:t>
+            </a:r>
+            <a:endParaRPr lang="en-US" sz="1500" dirty="0"/>
+          </a:p>
+        </p:txBody>
+      </p:sp>
+      <p:sp>
+        <p:nvSpPr>
+          <p:cNvPr id="13" name="Shape 11"/>
+          <p:cNvSpPr/>
+          <p:nvPr/>
+        </p:nvSpPr>
+        <p:spPr>
+          <a:xfrm>
+            <a:off x="4297680" y="2788920"/>
+            <a:ext cx="7132320" cy="1325880"/>
+          </a:xfrm>
+          <a:prstGeom prst="roundRect">
+            <a:avLst/>
+          </a:prstGeom>
+          <a:solidFill>
+            <a:srgbClr val="FFFFFF"/>
+          </a:solidFill>
+          <a:ln w="12700">
+            <a:solidFill>
+              <a:srgbClr val="CBD5E1"/>
+            </a:solidFill>
+            <a:prstDash val="solid"/>
+          </a:ln>
+        </p:spPr>
+      </p:sp>
+      <p:sp>
+        <p:nvSpPr>
+          <p:cNvPr id="14" name="Shape 12"/>
+          <p:cNvSpPr/>
+          <p:nvPr/>
+        </p:nvSpPr>
+        <p:spPr>
+          <a:xfrm>
+            <a:off x="4297680" y="2788920"/>
+            <a:ext cx="548640" cy="1325880"/>
+          </a:xfrm>
+          <a:prstGeom prst="roundRect">
+            <a:avLst/>
+          </a:prstGeom>
+          <a:solidFill>
+            <a:srgbClr val="06B6D4"/>
+          </a:solidFill>
+          <a:ln/>
+        </p:spPr>
+      </p:sp>
+      <p:sp>
+        <p:nvSpPr>
+          <p:cNvPr id="15" name="Text 13"/>
+          <p:cNvSpPr/>
+          <p:nvPr/>
+        </p:nvSpPr>
+        <p:spPr>
+          <a:xfrm>
+            <a:off x="4297680" y="2788920"/>
+            <a:ext cx="548640" cy="1325880"/>
+          </a:xfrm>
+          <a:prstGeom prst="rect">
+            <a:avLst/>
+          </a:prstGeom>
+          <a:noFill/>
+          <a:ln/>
+        </p:spPr>
+        <p:txBody>
+          <a:bodyPr wrap="square" rtlCol="0" anchor="ctr"/>
+          <a:lstStyle/>
+          <a:p>
+            <a:pPr algn="ctr" indent="0" marL="0">
+              <a:buNone/>
+            </a:pPr>
+            <a:r>
+              <a:rPr lang="en-US" sz="1600" b="1" dirty="0">
+                <a:solidFill>
+                  <a:srgbClr val="FFFFFF"/>
+                </a:solidFill>
+              </a:rPr>
+              <a:t>2</a:t>
+            </a:r>
+            <a:endParaRPr lang="en-US" sz="1600" dirty="0"/>
+          </a:p>
+        </p:txBody>
+      </p:sp>
+      <p:sp>
+        <p:nvSpPr>
+          <p:cNvPr id="16" name="Text 14"/>
+          <p:cNvSpPr/>
+          <p:nvPr/>
+        </p:nvSpPr>
+        <p:spPr>
+          <a:xfrm>
+            <a:off x="5029200" y="2880360"/>
+            <a:ext cx="6217920" cy="1143000"/>
+          </a:xfrm>
+          <a:prstGeom prst="rect">
+            <a:avLst/>
+          </a:prstGeom>
+          <a:noFill/>
+          <a:ln/>
+        </p:spPr>
+        <p:txBody>
+          <a:bodyPr wrap="square" rtlCol="0" anchor="ctr"/>
+          <a:lstStyle/>
+          <a:p>
+            <a:pPr indent="0" marL="0">
+              <a:buNone/>
+            </a:pPr>
+            <a:r>
+              <a:rPr lang="en-US" sz="1500" b="1" dirty="0">
+                <a:solidFill>
+                  <a:srgbClr val="1E293B"/>
+                </a:solidFill>
+              </a:rPr>
+              <a:t>Backend: Node.js + Express + MongoDB Atlas</a:t>
+            </a:r>
+            <a:endParaRPr lang="en-US" sz="1500" dirty="0"/>
+          </a:p>
+        </p:txBody>
+      </p:sp>
+      <p:sp>
+        <p:nvSpPr>
+          <p:cNvPr id="17" name="Shape 15"/>
+          <p:cNvSpPr/>
+          <p:nvPr/>
+        </p:nvSpPr>
+        <p:spPr>
+          <a:xfrm>
+            <a:off x="4297680" y="4297680"/>
+            <a:ext cx="7132320" cy="1325880"/>
+          </a:xfrm>
+          <a:prstGeom prst="roundRect">
+            <a:avLst/>
+          </a:prstGeom>
+          <a:solidFill>
+            <a:srgbClr val="FFFFFF"/>
+          </a:solidFill>
+          <a:ln w="12700">
+            <a:solidFill>
+              <a:srgbClr val="CBD5E1"/>
+            </a:solidFill>
+            <a:prstDash val="solid"/>
+          </a:ln>
+        </p:spPr>
+      </p:sp>
+      <p:sp>
+        <p:nvSpPr>
+          <p:cNvPr id="18" name="Shape 16"/>
+          <p:cNvSpPr/>
+          <p:nvPr/>
+        </p:nvSpPr>
+        <p:spPr>
+          <a:xfrm>
+            <a:off x="4297680" y="4297680"/>
+            <a:ext cx="548640" cy="1325880"/>
+          </a:xfrm>
+          <a:prstGeom prst="roundRect">
+            <a:avLst/>
+          </a:prstGeom>
+          <a:solidFill>
+            <a:srgbClr val="06B6D4"/>
+          </a:solidFill>
+          <a:ln/>
+        </p:spPr>
+      </p:sp>
+      <p:sp>
+        <p:nvSpPr>
+          <p:cNvPr id="19" name="Text 17"/>
+          <p:cNvSpPr/>
+          <p:nvPr/>
+        </p:nvSpPr>
+        <p:spPr>
+          <a:xfrm>
+            <a:off x="4297680" y="4297680"/>
+            <a:ext cx="548640" cy="1325880"/>
+          </a:xfrm>
+          <a:prstGeom prst="rect">
+            <a:avLst/>
+          </a:prstGeom>
+          <a:noFill/>
+          <a:ln/>
+        </p:spPr>
+        <p:txBody>
+          <a:bodyPr wrap="square" rtlCol="0" anchor="ctr"/>
+          <a:lstStyle/>
+          <a:p>
+            <a:pPr algn="ctr" indent="0" marL="0">
+              <a:buNone/>
+            </a:pPr>
+            <a:r>
+              <a:rPr lang="en-US" sz="1600" b="1" dirty="0">
+                <a:solidFill>
+                  <a:srgbClr val="FFFFFF"/>
+                </a:solidFill>
+              </a:rPr>
+              <a:t>3</a:t>
+            </a:r>
+            <a:endParaRPr lang="en-US" sz="1600" dirty="0"/>
+          </a:p>
+        </p:txBody>
+      </p:sp>
+      <p:sp>
+        <p:nvSpPr>
+          <p:cNvPr id="20" name="Text 18"/>
+          <p:cNvSpPr/>
+          <p:nvPr/>
+        </p:nvSpPr>
+        <p:spPr>
+          <a:xfrm>
+            <a:off x="5029200" y="4389120"/>
+            <a:ext cx="6217920" cy="1143000"/>
+          </a:xfrm>
+          <a:prstGeom prst="rect">
+            <a:avLst/>
+          </a:prstGeom>
+          <a:noFill/>
+          <a:ln/>
+        </p:spPr>
+        <p:txBody>
+          <a:bodyPr wrap="square" rtlCol="0" anchor="ctr"/>
+          <a:lstStyle/>
+          <a:p>
+            <a:pPr indent="0" marL="0">
+              <a:buNone/>
+            </a:pPr>
+            <a:r>
+              <a:rPr lang="en-US" sz="1500" b="1" dirty="0">
+                <a:solidFill>
+                  <a:srgbClr val="1E293B"/>
+                </a:solidFill>
+              </a:rPr>
+              <a:t>DevOps: Docker Containers + Nginx + GitHub Actions CI/CD</a:t>
+            </a:r>
+            <a:endParaRPr lang="en-US" sz="1500" dirty="0"/>
           </a:p>
         </p:txBody>
       </p:sp>

</xml_diff>